<commit_message>
Apply review fixes to Tosca MCP training materials and add verification report
- Correct module claim: MCP cannot scan screens for UI modules, but
  can create API modules
- Lab 2: change TestCaseWorkState via set_attribute to avoid a
  blocking dialog; extend T00 rule and troubleshooting
- Lab 3: reference the password through a TCP instead of typing it
  into the prompt
- Lab 4: save before each validation run
- Clarify that Tricentis ships the 18 workflow templates and the
  prompt templates were written for this course
- Move the break after Lab 3, fix multi-user save order and
  Unknown task guidance, add instructor prep checklist
- Make the deck builder write theme colors itself; add package.json

Co-Authored-By: Claude Opus 5.5 <noreply@anthropic.com>
Claude-Session: https://claude.ai/code/session_01626LBpPfoWb6LeDmH9KQxD
</commit_message>
<xml_diff>
--- a/tosca-mcp-training/Tosca_Commander_MCP_교육자료.pptx
+++ b/tosca-mcp-training/Tosca_Commander_MCP_교육자료.pptx
@@ -139,7 +139,7 @@
   <p:extLst>
     <p:ext uri="{521415D9-36F7-43E2-AB2F-B90AF26B5E84}">
       <p14:sectionLst xmlns:p14="http://schemas.microsoft.com/office/powerpoint/2010/main">
-        <p14:section name="오프닝" id="{dee6b258-5455-8f26-0a32-570f61b25c47}">
+        <p14:section name="오프닝" id="{f09c4df1-a6e6-698a-d490-98e43d704040}">
           <p14:sldIdLst>
             <p14:sldId id="256"/>
             <p14:sldId id="257"/>
@@ -147,7 +147,7 @@
             <p14:sldId id="259"/>
           </p14:sldIdLst>
         </p14:section>
-        <p14:section name="Part 1 Tosca MCP 이해" id="{c396bbf7-e99d-844c-193f-cc334f43eb2c}">
+        <p14:section name="Part 1 Tosca MCP 이해" id="{a3fae42c-7854-df4d-3710-d0d45d546636}">
           <p14:sldIdLst>
             <p14:sldId id="260"/>
             <p14:sldId id="261"/>
@@ -159,7 +159,7 @@
             <p14:sldId id="267"/>
           </p14:sldIdLst>
         </p14:section>
-        <p14:section name="Part 2 실습" id="{3e55aa8b-d2ad-4220-ec42-8934cd655504}">
+        <p14:section name="Part 2 실습" id="{0386a16b-4eca-3c5f-dd49-fa558b5e37c3}">
           <p14:sldIdLst>
             <p14:sldId id="268"/>
             <p14:sldId id="269"/>
@@ -173,7 +173,7 @@
             <p14:sldId id="277"/>
           </p14:sldIdLst>
         </p14:section>
-        <p14:section name="Part 3 활용과 프롬프트" id="{7f6f3b63-cca5-5c5c-af07-0b3638a1ea16}">
+        <p14:section name="Part 3 활용과 프롬프트" id="{72827106-021b-8c1c-da65-941be7a1c598}">
           <p14:sldIdLst>
             <p14:sldId id="278"/>
             <p14:sldId id="279"/>
@@ -183,7 +183,7 @@
             <p14:sldId id="283"/>
           </p14:sldIdLst>
         </p14:section>
-        <p14:section name="Part 4 프롬프트 템플릿" id="{ff19c9e1-3c58-189e-799c-fc932579a50d}">
+        <p14:section name="Part 4 프롬프트 템플릿" id="{ab9166b2-3628-323d-b9a6-a3ea47840a4f}">
           <p14:sldIdLst>
             <p14:sldId id="284"/>
             <p14:sldId id="285"/>
@@ -191,7 +191,7 @@
             <p14:sldId id="287"/>
           </p14:sldIdLst>
         </p14:section>
-        <p14:section name="마무리" id="{8d423fee-b9fa-72d7-ebd3-3f6e461f2174}">
+        <p14:section name="마무리" id="{fdd8116f-e2c2-214d-346e-47ad738d0173}">
           <p14:sldIdLst>
             <p14:sldId id="288"/>
           </p14:sldIdLst>
@@ -776,7 +776,7 @@
           <a:p>
             <a:r>
               <a:rPr lang="en-US" dirty="0"/>
-              <a:t>할 수 있는 것만큼 중요한 게 맡기면 안 되는 것이다. 화면 스캔은 AI가 못 한다. 기존 모듈만 쓴다. 비밀번호 같은 민감 정보는 사람이 넣는다. Data Integrity 연결을 AI가 만들면 Allow AI queries 옵션이 꺼진 채로 만들어지고, 켜는 건 사람이 Connection Manager에서 한다. 삭제는 되돌릴 수 없으니 목록 확인 후 따로 승인한다. 실패가 진짜 결함인지 판단하는 것도 사람 몫이다. 테스트를 고쳐서 결함을 덮으면 안 된다.</a:t>
+              <a:t>AI에게 맡기지 않을 일도 미리 정해 둔다. 화면 스캔은 AI가 못 한다. UI 모듈은 사람이 XScan으로 만든다. 비밀번호 같은 민감 정보는 사람이 넣는다. Data Integrity 연결을 AI가 만들면 Allow AI queries 옵션이 꺼진 채로 만들어지고, 켜는 건 사람이 Connection Manager에서 한다. 삭제는 되돌릴 수 없으니 목록 확인 후 따로 승인한다. 실패가 진짜 결함인지 판단하는 것도 사람 몫이다. 테스트를 고쳐서 결함을 덮으면 안 된다.</a:t>
             </a:r>
             <a:endParaRPr lang="en-US" dirty="0"/>
           </a:p>
@@ -864,7 +864,7 @@
           <a:p>
             <a:r>
               <a:rPr lang="en-US" dirty="0"/>
-              <a:t>실습 전에 이 네 가지가 준비돼 있어야 한다. Commander는 2026.1 LTS Patch 1 이상이어야 하고, Patch 1이라면 MCP Server 애드인을 직접 켜야 한다. AI 클라이언트는 Tricentis가 테스트했다고 밝힌 네 가지 중 하나를 쓴다. 설정은 서버 주소 한 줄이 전부다. 오른쪽은 VS Code 예시이고, 나머지 클라이언트 설정은 워크북 2장에 있다. 스킬팩은 필수는 아니지만 Tricentis도 함께 쓰기를 권한다. 설치하면 AI가 체크아웃, 저장 같은 규칙을 알아서 지킨다.</a:t>
+              <a:t>실습 전에 이 네 가지가 준비돼 있어야 한다. Commander는 2026.1 LTS Patch 1 이상이어야 하고, Patch 1이라면 MCP Server 애드인을 직접 켜야 한다. AI 클라이언트는 Tricentis가 테스트했다고 밝힌 네 가지 중 하나를 쓴다. 설정은 서버 주소 한 줄이 전부다. 오른쪽은 VS Code 예시이고, 나머지 클라이언트 설정은 워크북 2장에 있다. 스킬팩은 Tricentis 문서가 함께 쓰라고 권하고, 스킬팩 안내서에는 MCP 연결과 스킬팩이 둘 다 필요하다고 되어 있다. 이 과정은 설치를 전제로 한다. 설치하면 AI가 체크아웃, 저장, 대화상자를 여는 작업 피하기 같은 규칙을 알아서 지킨다.</a:t>
             </a:r>
             <a:endParaRPr lang="en-US" dirty="0"/>
           </a:p>
@@ -1040,7 +1040,7 @@
           <a:p>
             <a:r>
               <a:rPr lang="en-US" dirty="0"/>
-              <a:t>실습 대상은 Tricentis가 공개한 연습용 쇼핑몰 Demo Web Shop이다. 시나리오는 로그인하고, 계정 이메일이 맞게 보이는지 검증하고, 로그아웃하는 것. 모듈은 미리 XScan으로 스캔해서 워크스페이스에 넣어 두었다. MCP로는 모듈을 만들 수 없기 때문이다. 실습 계정은 따로 나눠 준다. 사내 앱으로 바꿔도 흐름은 똑같다.</a:t>
+              <a:t>실습 대상은 Tricentis가 공개한 연습용 쇼핑몰 Demo Web Shop이다. 시나리오는 로그인하고, 계정 이메일이 맞게 보이는지 검증하고, 로그아웃하는 것. 모듈은 미리 XScan으로 스캔해서 워크스페이스에 넣어 두었다. AI는 화면을 스캔해 모듈을 만들 수 없기 때문이다. 실습 계정 이메일은 따로 나눠 주고, 비밀번호는 TCP로 넣어 두었다. 사내 앱으로 바꿔도 흐름은 똑같다.</a:t>
             </a:r>
             <a:endParaRPr lang="en-US" dirty="0"/>
           </a:p>
@@ -1568,7 +1568,7 @@
           <a:p>
             <a:r>
               <a:rPr lang="en-US" dirty="0"/>
-              <a:t>전체 3시간 20분 중 절반 가까이가 실습이다. 이론은 실습에 필요한 만큼만 다룬다. Part 2 실습은 Lab 0부터 Lab 5까지 순서대로 진행하는데, 앞 Lab에서 만든 결과를 뒤 Lab에서 쓰기 때문에 건너뛰지 않는다. 휴식은 Part 2가 끝난 뒤 10분.</a:t>
+              <a:t>전체 3시간 20분 중 절반 가까이가 실습이다. 이론은 실습에 필요한 만큼만 다룬다. Part 2 실습은 Lab 0부터 Lab 5까지 순서대로 진행하는데, 앞 Lab에서 만든 결과를 뒤 Lab에서 쓰기 때문에 건너뛰지 않는다. 휴식은 Lab 3가 끝난 뒤 10분. 그 전까지 95분이므로 집중이 떨어지지 않게 Lab 사이사이 진행 상황을 확인한다.</a:t>
             </a:r>
             <a:endParaRPr lang="en-US" dirty="0"/>
           </a:p>
@@ -1656,7 +1656,7 @@
           <a:p>
             <a:r>
               <a:rPr lang="en-US" dirty="0"/>
-              <a:t>계획이 맞으면 3-2로 승인한다. AI가 만든 뒤에는 스텝 구조를 다시 읽어 달라고 해서 계획과 같은지 본다. 그리고 반드시 Commander에서 직접 열어 본다. 만약 모듈을 못 찾았다는 답이 오면, 그 화면은 사람이 XScan으로 스캔한 다음 같은 프롬프트로 다시 요청하면 된다. 비밀번호는 실습이라 그대로 넣지만, 실무에서는 사내 규칙대로 관리한다.</a:t>
+              <a:t>계획이 맞으면 3-2로 승인한다. AI가 만든 뒤에는 스텝 구조를 다시 읽어 달라고 해서 계획과 같은지 본다. 그리고 반드시 Commander에서 직접 열어 본다. Password 값이 실제 비밀번호가 아니라 {CP[DWS_Password]} 참조인지도 본다. 비밀번호를 프롬프트에 쓰면 클라우드 모델로 넘어가기 때문이다. 모듈을 못 찾았다는 답이 오면, 그 화면은 사람이 XScan으로 스캔한 다음 같은 프롬프트로 다시 요청한다. 두세 번 고쳐도 안 되면 완성본을 복사해 Lab 4로 넘어간다. 여기까지 끝나면 10분 휴식.</a:t>
             </a:r>
             <a:endParaRPr lang="en-US" dirty="0"/>
           </a:p>
@@ -1832,7 +1832,7 @@
           <a:p>
             <a:r>
               <a:rPr lang="en-US" dirty="0"/>
-              <a:t>마지막으로 오늘 만든 것을 정리하고 저장한다. 싱글 유저는 저장으로 끝이다. 멀티 유저라면 저장 후 체크인까지 해야 다른 사람에게 보인다. 체크인 전에는 바뀐 객체 목록을 먼저 보는 습관을 들인다. 오른쪽은 실습에서 자주 막히는 지점이다. 전체 목록은 워크북 부록 B에 있다.</a:t>
+              <a:t>마지막으로 오늘 만든 것을 정리하고 저장한다. 테스트케이스는 만들 때 이미 저장됐으니, 여기서 저장하는 건 Lab 4처럼 값을 바꾼 것이다. 싱글 유저는 저장으로 끝이다. 멀티 유저라면 시작할 때 update_all로 최신 내용을 받고, 고칠 객체를 체크아웃하고, 끝에 저장과 체크인을 한다. 체크인은 내가 체크아웃한 객체 전부에 적용되므로 목록을 먼저 본다. 오른쪽은 실습에서 자주 막히는 지점이다. 전체 목록은 워크북 부록 B에 있다.</a:t>
             </a:r>
             <a:endParaRPr lang="en-US" dirty="0"/>
           </a:p>
@@ -2008,7 +2008,7 @@
           <a:p>
             <a:r>
               <a:rPr lang="en-US" dirty="0"/>
-              <a:t>Commander MCP를 쓰는 팀에서 자주 나오는 쓰임새를 여섯 가지로 묶었다. 각 카드 아래에는 사람이 꼭 확인해야 할 것과, 바로 쓸 수 있는 템플릿 번호를 적어 두었다. 오늘 실습은 1번과 2번이었다. 4번 실패 원인 분석은 매일 아침 야간 실행 결과를 볼 때 특히 쓸모가 크다. 6번은 라이선스와 권한 설정이 필요하다.</a:t>
+              <a:t>공식 워크플로와 도구를 기준으로 업무에 바로 적용해 볼 수 있는 쓰임새를 여섯 가지로 묶었다. 각 카드 아래에는 사람이 꼭 확인해야 할 것과 바로 쓸 수 있는 템플릿 번호를 적어 두었다. 오늘 실습은 1번과 2번이었다. 4번 실패 원인 분석은 야간 실행 결과를 볼 때 쓸모가 크다. 6번 중 API 모듈 만들기는 대응하는 공식 워크플로가 없어 템플릿이 없으므로 네 요소로 직접 쓴다. Data Integrity는 라이선스와 권한 설정이 필요하다.</a:t>
             </a:r>
             <a:endParaRPr lang="en-US" dirty="0"/>
           </a:p>
@@ -2184,7 +2184,7 @@
           <a:p>
             <a:r>
               <a:rPr lang="en-US" dirty="0"/>
-              <a:t>Tricentis는 MCP 프롬프트를 쓸 때 구체적으로, 맥락을 주고, 단계를 나누라고 권한다. 이걸 실무에서 바로 쓰기 좋게 대상, 작업, 조건, 확인 네 가지로 정리했다. 대상은 어디서, 작업은 무엇을, 조건은 어떻게, 확인은 결과를 어떻게 받을지다. 아래 예시처럼 네 가지가 다 들어가면 AI가 추측할 여지가 거의 없다.</a:t>
+              <a:t>Tricentis는 MCP 프롬프트를 쓸 때 구체적으로 쓰고, 맥락을 주고, 단계를 나눠 요청하라고 권한다. 이걸 실무에서 바로 쓰기 좋게 대상, 작업, 조건, 확인 네 가지로 정리했다. 대상은 어디서, 작업은 무엇을, 조건은 어떻게, 확인은 결과를 어떻게 받을지다. 아래 예시처럼 네 가지가 다 들어가면 AI가 추측할 여지가 거의 없다.</a:t>
             </a:r>
             <a:endParaRPr lang="en-US" dirty="0"/>
           </a:p>
@@ -2360,7 +2360,7 @@
           <a:p>
             <a:r>
               <a:rPr lang="en-US" dirty="0"/>
-              <a:t>일곱 가지 중 하나만 고르라면 세 번째, 바꾸는 일은 계획부터다. 계획을 보면 AI가 무엇을 오해했는지 실행 전에 알 수 있다. 나머지는 계획을 더 정확하게 만들기 위한 습관이다. 공통 머리말 템플릿 T00에 이 습관들을 규칙으로 넣어 두었다. 대화 시작할 때 한 번 붙여 넣으면 된다.</a:t>
+              <a:t>일곱 가지 중 가장 중요한 것은 세 번째, 바꾸는 일은 계획부터다. 계획을 보면 AI가 무엇을 오해했는지 실행 전에 알 수 있다. 나머지는 계획을 더 정확하게 만들기 위한 요령이다. 공통 머리말 템플릿 T00에 이 요령들을 규칙으로 넣어 두었다. 대화 시작할 때 한 번 붙여 넣으면 된다.</a:t>
             </a:r>
             <a:endParaRPr lang="en-US" dirty="0"/>
           </a:p>
@@ -2624,7 +2624,7 @@
           <a:p>
             <a:r>
               <a:rPr lang="en-US" dirty="0"/>
-              <a:t>Tricentis가 공개한 commander-mcp 스킬팩 1.2.1에는 AI가 따라 하는 작업 순서, 즉 워크플로 템플릿 18종이 들어 있다. 이건 AI용이다. 우리는 이 18종에 하나씩 대응하는 사람용 프롬프트 템플릿을 만들었다. 번호와 순서가 공식 워크플로와 같아서, 스킬팩을 설치한 상태라면 AI가 해당 워크플로를 그대로 따른다. 여섯 묶음 중 실행·분석이 7종으로 가장 많다.</a:t>
+              <a:t>먼저 구분할 것이 있다. Tricentis가 공개한 commander-mcp 스킬팩 1.2.1에 들어 있는 것은 AI가 따라 하는 작업 순서, 즉 워크플로 템플릿 18종이다. 이건 AI용이고 Tricentis가 제공한다. 사람이 입력하는 프롬프트 템플릿 T00~T18은 이 과정에서 그 18종에 하나씩 맞춰 만든 것이다. 번호는 대응 관계를 찾기 쉽게 공식 목록 순서를 따랐다. 스킬팩이 설치돼 있으면 AI는 요청 내용에 맞는 워크플로를 골라 따르고, 템플릿은 그 워크플로에 필요한 정보를 빠짐없이 주는 역할을 한다.</a:t>
             </a:r>
             <a:endParaRPr lang="en-US" dirty="0"/>
           </a:p>
@@ -2976,7 +2976,7 @@
           <a:p>
             <a:r>
               <a:rPr lang="en-US" dirty="0"/>
-              <a:t>Tosca 테스트는 화면을 스캔해 모듈을 만들고, 모듈을 조합해 테스트케이스를 만들고, 실행해서 결과를 보는 순서로 만들어진다. MCP로 AI가 도와줄 수 있는 구간은 2번부터 5번까지다. 1번 화면 스캔은 XScan 화면에서 사람이 해야 한다. 그래서 실습용 모듈은 미리 준비해 두었다.</a:t>
+              <a:t>Tosca 테스트는 화면을 스캔해 모듈을 만들고, 모듈을 조합해 테스트케이스를 만들고, 실행해서 결과를 보는 순서로 만들어진다. MCP로 AI가 도와줄 수 있는 구간은 2번부터 5번까지다. 2번은 이미 있는 모듈을 찾아 쓰는 것까지다. 1번 화면 스캔은 XScan 화면에서 사람이 해야 하고, AI는 화면을 스캔해 UI 모듈을 만들 수 없다. 그래서 실습용 모듈은 미리 준비해 두었다. 참고로 API 모듈은 MCP 도구로 만들 수 있다.</a:t>
             </a:r>
             <a:endParaRPr lang="en-US" dirty="0"/>
           </a:p>
@@ -3152,7 +3152,7 @@
           <a:p>
             <a:r>
               <a:rPr lang="en-US" dirty="0"/>
-              <a:t>MCP는 Model Context Protocol의 약자다. AI 앱이 외부 프로그램의 기능을 도구처럼 불러 쓸 수 있게 해 주는 공개 규격이다. 예전에는 AI 앱과 프로그램을 잇는 연동을 조합마다 따로 만들어야 했다. MCP가 생긴 뒤로는 각자 규격 하나만 맞추면 된다. 그래서 USB-C에 자주 비유한다. 2024년 11월 Anthropic이 공개했고, 2025년 12월 Linux Foundation 산하 Agentic AI Foundation으로 넘어갔다. Tricentis도 이 규격으로 Tosca용 서버를 만들었다.</a:t>
+              <a:t>MCP는 Model Context Protocol의 약자다. AI 앱이 외부 프로그램의 기능을 도구처럼 불러 쓸 수 있게 해 주는 공개 규격이다. 예전에는 AI 앱과 프로그램을 잇는 연동을 조합마다 따로 만들어야 했다. MCP가 생긴 뒤로는 각자 규격 하나만 맞추면 된다. Tosca 입장에서는 서버 하나만 만들면 Copilot, Cursor, Claude 어디서든 붙는다는 뜻이다. 2024년 11월 Anthropic이 공개했고, 2025년 12월 Linux Foundation 산하 Agentic AI Foundation으로 넘어갔다.</a:t>
             </a:r>
             <a:endParaRPr lang="en-US" dirty="0"/>
           </a:p>
@@ -6574,7 +6574,7 @@
                   <a:schemeClr val="tx1"/>
                 </a:solidFill>
               </a:rPr>
-              <a:t>AI는 이미 있는 모듈만 재사용한다. 새 화면은 사람이 XScan으로 스캔한다.</a:t>
+              <a:t>AI는 화면을 스캔해 UI 모듈을 만들지 못한다. 새 화면은 사람이 XScan으로 스캔한다.</a:t>
             </a:r>
             <a:endParaRPr lang="en-US" sz="1400" dirty="0"/>
           </a:p>
@@ -7800,7 +7800,7 @@
                   <a:schemeClr val="tx1"/>
                 </a:solidFill>
               </a:rPr>
-              <a:t>commander-mcp 스킬팩 (권장)</a:t>
+              <a:t>commander-mcp 스킬팩</a:t>
             </a:r>
             <a:endParaRPr lang="en-US" sz="1600" dirty="0"/>
           </a:p>
@@ -7836,7 +7836,7 @@
                   <a:schemeClr val="accent6"/>
                 </a:solidFill>
               </a:rPr>
-              <a:t>github.com/Tricentis/mcp-skills 의 Tosca/Commander/MCP</a:t>
+              <a:t>MCP 연결과 함께 설치. github.com/Tricentis/mcp-skills</a:t>
             </a:r>
             <a:endParaRPr lang="en-US" sz="1300" dirty="0"/>
           </a:p>
@@ -9920,7 +9920,7 @@
                   <a:schemeClr val="tx1"/>
                 </a:solidFill>
               </a:rPr>
-              <a:t>Header, Login은 강사가 XScan으로 미리 스캔했다. MCP는 모듈을 새로 만들지 않으므로, 없는 화면은 사람이 먼저 스캔해야 한다.</a:t>
+              <a:t>Header, Login은 강사가 XScan으로 미리 스캔했다. AI는 화면을 스캔하지 못하므로, 없는 화면은 사람이 먼저 스캔해야 한다.</a:t>
             </a:r>
             <a:endParaRPr lang="en-US" sz="1400" dirty="0"/>
           </a:p>
@@ -11313,6 +11313,20 @@
             </a:r>
             <a:endParaRPr lang="en-US" sz="1600" dirty="0"/>
           </a:p>
+          <a:p>
+            <a:pPr indent="0" marL="0">
+              <a:buNone/>
+            </a:pPr>
+            <a:r>
+              <a:rPr lang="en-US" sz="1300" dirty="0">
+                <a:solidFill>
+                  <a:schemeClr val="accent6"/>
+                </a:solidFill>
+              </a:rPr>
+              <a:t>테스트케이스는 만들 때 바로 저장된다. 값을 바꾼 경우에만 저장을 따로 요청한다.</a:t>
+            </a:r>
+            <a:endParaRPr lang="en-US" sz="1600" dirty="0"/>
+          </a:p>
         </p:txBody>
       </p:sp>
       <p:sp>
@@ -14280,7 +14294,7 @@
                   <a:schemeClr val="tx1"/>
                 </a:solidFill>
               </a:rPr>
-              <a:t>작업 상태(TestCaseWorkState)는 IN_WORK로 해줘.</a:t>
+              <a:t>작업 상태(TestCaseWorkState)는 IN_WORK로 해줘. 메뉴 작업 말고 속성 변경(set_attribute)으로 바꿔.</a:t>
             </a:r>
             <a:endParaRPr lang="en-US" sz="1300" dirty="0"/>
           </a:p>
@@ -15423,7 +15437,7 @@
                   <a:schemeClr val="tx1"/>
                 </a:solidFill>
               </a:rPr>
-              <a:t>  3. Login 모듈에 Email [실습 이메일], Password [실습 비밀번호] 입력 후 Log in 클릭</a:t>
+              <a:t>  3. Login 모듈에 Email [실습 이메일], Password {CP[DWS_Password]} 입력 후 Log in 클릭</a:t>
             </a:r>
             <a:endParaRPr lang="en-US" sz="1250" dirty="0"/>
           </a:p>
@@ -16050,7 +16064,7 @@
                             <a:schemeClr val="tx1"/>
                           </a:solidFill>
                         </a:rPr>
-                        <a:t>demowebshop.tricentis.com</a:t>
+                        <a:t>https://demowebshop.tricentis.com</a:t>
                       </a:r>
                       <a:endParaRPr lang="en-US" sz="1050" dirty="0"/>
                     </a:p>
@@ -16969,10 +16983,17 @@
                           <a:solidFill>
                             <a:schemeClr val="tx1"/>
                           </a:solidFill>
+                          <a:latin typeface="Consolas" pitchFamily="34" charset="0"/>
+                          <a:ea typeface="Consolas" pitchFamily="34" charset="-122"/>
+                          <a:cs typeface="Consolas" pitchFamily="34" charset="-120"/>
                         </a:rPr>
-                        <a:t>[실습 비밀번호]</a:t>
+                        <a:t>{CP[DWS_Password]}</a:t>
                       </a:r>
-                      <a:endParaRPr lang="en-US" sz="1050" dirty="0"/>
+                      <a:endParaRPr lang="en-US" sz="1050" dirty="0">
+                        <a:latin typeface="Consolas" charset="0"/>
+                        <a:ea typeface="Consolas" charset="0"/>
+                        <a:cs typeface="Consolas" charset="0"/>
+                      </a:endParaRPr>
                     </a:p>
                   </a:txBody>
                   <a:tcPr marL="54864" marR="54864" marT="27432" marB="27432" anchor="ctr">
@@ -18645,7 +18666,7 @@
                   <a:schemeClr val="accent6"/>
                 </a:solidFill>
               </a:rPr>
-              <a:t>휴식 10분 포함</a:t>
+              <a:t>휴식 10분 포함 (Lab 3 뒤)</a:t>
             </a:r>
             <a:endParaRPr lang="en-US" sz="1400" dirty="0"/>
           </a:p>
@@ -19958,7 +19979,7 @@
         </p:nvSpPr>
         <p:spPr>
           <a:xfrm>
-            <a:off x="548640" y="3218688"/>
+            <a:off x="548640" y="3191256"/>
             <a:ext cx="219456" cy="219456"/>
           </a:xfrm>
           <a:prstGeom prst="roundRect">
@@ -19985,8 +20006,8 @@
         </p:nvSpPr>
         <p:spPr>
           <a:xfrm>
-            <a:off x="896112" y="3154680"/>
-            <a:ext cx="5138928" cy="457200"/>
+            <a:off x="896112" y="3127248"/>
+            <a:ext cx="5138928" cy="411480"/>
           </a:xfrm>
           <a:prstGeom prst="rect">
             <a:avLst/>
@@ -20002,14 +20023,14 @@
               <a:buNone/>
             </a:pPr>
             <a:r>
-              <a:rPr lang="en-US" sz="1400" dirty="0">
+              <a:rPr lang="en-US" sz="1350" dirty="0">
                 <a:solidFill>
                   <a:schemeClr val="tx1"/>
                 </a:solidFill>
               </a:rPr>
               <a:t>계획 표를 먼저 받았고, 모든 스텝에 모듈이 매칭됐다</a:t>
             </a:r>
-            <a:endParaRPr lang="en-US" sz="1400" dirty="0"/>
+            <a:endParaRPr lang="en-US" sz="1350" dirty="0"/>
           </a:p>
         </p:txBody>
       </p:sp>
@@ -20021,7 +20042,7 @@
         </p:nvSpPr>
         <p:spPr>
           <a:xfrm>
-            <a:off x="548640" y="3675888"/>
+            <a:off x="548640" y="3602736"/>
             <a:ext cx="219456" cy="219456"/>
           </a:xfrm>
           <a:prstGeom prst="roundRect">
@@ -20048,8 +20069,8 @@
         </p:nvSpPr>
         <p:spPr>
           <a:xfrm>
-            <a:off x="896112" y="3611880"/>
-            <a:ext cx="5138928" cy="457200"/>
+            <a:off x="896112" y="3538728"/>
+            <a:ext cx="5138928" cy="411480"/>
           </a:xfrm>
           <a:prstGeom prst="rect">
             <a:avLst/>
@@ -20065,14 +20086,14 @@
               <a:buNone/>
             </a:pPr>
             <a:r>
-              <a:rPr lang="en-US" sz="1400" dirty="0">
+              <a:rPr lang="en-US" sz="1350" dirty="0">
                 <a:solidFill>
                   <a:schemeClr val="tx1"/>
                 </a:solidFill>
               </a:rPr>
               <a:t>4번 스텝(Account)의 ActionMode가 Verify다</a:t>
             </a:r>
-            <a:endParaRPr lang="en-US" sz="1400" dirty="0"/>
+            <a:endParaRPr lang="en-US" sz="1350" dirty="0"/>
           </a:p>
         </p:txBody>
       </p:sp>
@@ -20084,7 +20105,7 @@
         </p:nvSpPr>
         <p:spPr>
           <a:xfrm>
-            <a:off x="548640" y="4133088"/>
+            <a:off x="548640" y="4014216"/>
             <a:ext cx="219456" cy="219456"/>
           </a:xfrm>
           <a:prstGeom prst="roundRect">
@@ -20111,8 +20132,8 @@
         </p:nvSpPr>
         <p:spPr>
           <a:xfrm>
-            <a:off x="896112" y="4069080"/>
-            <a:ext cx="5138928" cy="457200"/>
+            <a:off x="896112" y="3950208"/>
+            <a:ext cx="5138928" cy="411480"/>
           </a:xfrm>
           <a:prstGeom prst="rect">
             <a:avLst/>
@@ -20128,14 +20149,14 @@
               <a:buNone/>
             </a:pPr>
             <a:r>
-              <a:rPr lang="en-US" sz="1400" dirty="0">
+              <a:rPr lang="en-US" sz="1350" dirty="0">
                 <a:solidFill>
                   <a:schemeClr val="tx1"/>
                 </a:solidFill>
               </a:rPr>
-              <a:t>결과 표가 계획 표(기대 스텝)와 같다</a:t>
-            </a:r>
-            <a:endParaRPr lang="en-US" sz="1400" dirty="0"/>
+              <a:t>Password 값이 {CP[DWS_Password]} 참조로 들어갔다 (실제 비밀번호가 아님)</a:t>
+            </a:r>
+            <a:endParaRPr lang="en-US" sz="1350" dirty="0"/>
           </a:p>
         </p:txBody>
       </p:sp>
@@ -20147,7 +20168,7 @@
         </p:nvSpPr>
         <p:spPr>
           <a:xfrm>
-            <a:off x="548640" y="4590288"/>
+            <a:off x="548640" y="4425696"/>
             <a:ext cx="219456" cy="219456"/>
           </a:xfrm>
           <a:prstGeom prst="roundRect">
@@ -20174,8 +20195,8 @@
         </p:nvSpPr>
         <p:spPr>
           <a:xfrm>
-            <a:off x="896112" y="4526280"/>
-            <a:ext cx="5138928" cy="457200"/>
+            <a:off x="896112" y="4361688"/>
+            <a:ext cx="5138928" cy="411480"/>
           </a:xfrm>
           <a:prstGeom prst="rect">
             <a:avLst/>
@@ -20191,31 +20212,94 @@
               <a:buNone/>
             </a:pPr>
             <a:r>
-              <a:rPr lang="en-US" sz="1400" dirty="0">
+              <a:rPr lang="en-US" sz="1350" dirty="0">
                 <a:solidFill>
                   <a:schemeClr val="tx1"/>
                 </a:solidFill>
               </a:rPr>
-              <a:t>Commander에서 스텝과 값을 직접 확인했다</a:t>
-            </a:r>
-            <a:endParaRPr lang="en-US" sz="1400" dirty="0"/>
-          </a:p>
-        </p:txBody>
-      </p:sp>
-      <p:sp>
-        <p:nvSpPr>
-          <p:cNvPr id="18" name="card_528"/>
+              <a:t>결과 표가 계획 표(기대 스텝)와 같다</a:t>
+            </a:r>
+            <a:endParaRPr lang="en-US" sz="1350" dirty="0"/>
+          </a:p>
+        </p:txBody>
+      </p:sp>
+      <p:sp>
+        <p:nvSpPr>
+          <p:cNvPr id="18" name="checkbox_528"/>
           <p:cNvSpPr/>
           <p:nvPr/>
         </p:nvSpPr>
         <p:spPr>
           <a:xfrm>
-            <a:off x="548640" y="5120640"/>
-            <a:ext cx="5486400" cy="1051560"/>
+            <a:off x="548640" y="4837176"/>
+            <a:ext cx="219456" cy="219456"/>
           </a:xfrm>
           <a:prstGeom prst="roundRect">
             <a:avLst>
-              <a:gd name="adj" fmla="val 8696"/>
+              <a:gd name="adj" fmla="val 16667"/>
+            </a:avLst>
+          </a:prstGeom>
+          <a:solidFill>
+            <a:schemeClr val="bg1"/>
+          </a:solidFill>
+          <a:ln w="12700">
+            <a:solidFill>
+              <a:schemeClr val="accent1"/>
+            </a:solidFill>
+            <a:prstDash val="solid"/>
+          </a:ln>
+        </p:spPr>
+      </p:sp>
+      <p:sp>
+        <p:nvSpPr>
+          <p:cNvPr id="19" name="text_529"/>
+          <p:cNvSpPr txBox="1"/>
+          <p:nvPr/>
+        </p:nvSpPr>
+        <p:spPr>
+          <a:xfrm>
+            <a:off x="896112" y="4773168"/>
+            <a:ext cx="5138928" cy="411480"/>
+          </a:xfrm>
+          <a:prstGeom prst="rect">
+            <a:avLst/>
+          </a:prstGeom>
+          <a:noFill/>
+          <a:ln/>
+        </p:spPr>
+        <p:txBody>
+          <a:bodyPr wrap="square" lIns="0" tIns="0" rIns="0" bIns="0" rtlCol="0" anchor="ctr"/>
+          <a:lstStyle/>
+          <a:p>
+            <a:pPr indent="0" marL="0">
+              <a:buNone/>
+            </a:pPr>
+            <a:r>
+              <a:rPr lang="en-US" sz="1350" dirty="0">
+                <a:solidFill>
+                  <a:schemeClr val="tx1"/>
+                </a:solidFill>
+              </a:rPr>
+              <a:t>Commander에서 스텝과 값을 직접 확인했다</a:t>
+            </a:r>
+            <a:endParaRPr lang="en-US" sz="1350" dirty="0"/>
+          </a:p>
+        </p:txBody>
+      </p:sp>
+      <p:sp>
+        <p:nvSpPr>
+          <p:cNvPr id="20" name="card_530"/>
+          <p:cNvSpPr/>
+          <p:nvPr/>
+        </p:nvSpPr>
+        <p:spPr>
+          <a:xfrm>
+            <a:off x="548640" y="5349240"/>
+            <a:ext cx="5486400" cy="822960"/>
+          </a:xfrm>
+          <a:prstGeom prst="roundRect">
+            <a:avLst>
+              <a:gd name="adj" fmla="val 11111"/>
             </a:avLst>
           </a:prstGeom>
           <a:solidFill>
@@ -20228,7 +20312,7 @@
       </p:sp>
       <p:pic>
         <p:nvPicPr>
-          <p:cNvPr id="19" name="icon_529" descr="preencoded.png">    </p:cNvPr>
+          <p:cNvPr id="21" name="icon_531" descr="preencoded.png">    </p:cNvPr>
           <p:cNvPicPr>
             <a:picLocks noChangeAspect="1"/>
           </p:cNvPicPr>
@@ -20242,7 +20326,7 @@
         </p:blipFill>
         <p:spPr>
           <a:xfrm>
-            <a:off x="749808" y="5349240"/>
+            <a:off x="749808" y="5559552"/>
             <a:ext cx="384048" cy="384048"/>
           </a:xfrm>
           <a:prstGeom prst="rect">
@@ -20252,14 +20336,14 @@
       </p:pic>
       <p:sp>
         <p:nvSpPr>
-          <p:cNvPr id="20" name="text_530"/>
-          <p:cNvSpPr txBox="1"/>
-          <p:nvPr/>
-        </p:nvSpPr>
-        <p:spPr>
-          <a:xfrm>
-            <a:off x="1280160" y="5166360"/>
-            <a:ext cx="4617720" cy="960120"/>
+          <p:cNvPr id="22" name="text_532"/>
+          <p:cNvSpPr txBox="1"/>
+          <p:nvPr/>
+        </p:nvSpPr>
+        <p:spPr>
+          <a:xfrm>
+            <a:off x="1280160" y="5349240"/>
+            <a:ext cx="4617720" cy="822960"/>
           </a:xfrm>
           <a:prstGeom prst="rect">
             <a:avLst/>
@@ -20275,20 +20359,20 @@
               <a:buNone/>
             </a:pPr>
             <a:r>
-              <a:rPr lang="en-US" sz="1400" dirty="0">
+              <a:rPr lang="en-US" sz="1350" dirty="0">
                 <a:solidFill>
                   <a:schemeClr val="tx1"/>
                 </a:solidFill>
               </a:rPr>
               <a:t>모듈이 없다는 답이 오면: 사람이 XScan으로 스캔 → 같은 프롬프트로 다시 요청</a:t>
             </a:r>
-            <a:endParaRPr lang="en-US" sz="1400" dirty="0"/>
-          </a:p>
-        </p:txBody>
-      </p:sp>
-      <p:sp>
-        <p:nvSpPr>
-          <p:cNvPr id="21" name="tree_531"/>
+            <a:endParaRPr lang="en-US" sz="1350" dirty="0"/>
+          </a:p>
+        </p:txBody>
+      </p:sp>
+      <p:sp>
+        <p:nvSpPr>
+          <p:cNvPr id="23" name="tree_533"/>
           <p:cNvSpPr/>
           <p:nvPr/>
         </p:nvSpPr>
@@ -20322,7 +20406,7 @@
       </p:sp>
       <p:sp>
         <p:nvSpPr>
-          <p:cNvPr id="22" name="treehead_532"/>
+          <p:cNvPr id="24" name="treehead_534"/>
           <p:cNvSpPr/>
           <p:nvPr/>
         </p:nvSpPr>
@@ -20344,7 +20428,7 @@
       </p:sp>
       <p:sp>
         <p:nvSpPr>
-          <p:cNvPr id="23" name="treehead2_533"/>
+          <p:cNvPr id="25" name="treehead2_535"/>
           <p:cNvSpPr/>
           <p:nvPr/>
         </p:nvSpPr>
@@ -20364,7 +20448,7 @@
       </p:sp>
       <p:sp>
         <p:nvSpPr>
-          <p:cNvPr id="24" name="text_534"/>
+          <p:cNvPr id="26" name="text_536"/>
           <p:cNvSpPr txBox="1"/>
           <p:nvPr/>
         </p:nvSpPr>
@@ -20400,7 +20484,7 @@
       </p:sp>
       <p:pic>
         <p:nvPicPr>
-          <p:cNvPr id="25" name="icon_535" descr="preencoded.png">    </p:cNvPr>
+          <p:cNvPr id="27" name="icon_537" descr="preencoded.png">    </p:cNvPr>
           <p:cNvPicPr>
             <a:picLocks noChangeAspect="1"/>
           </p:cNvPicPr>
@@ -20424,7 +20508,7 @@
       </p:pic>
       <p:sp>
         <p:nvSpPr>
-          <p:cNvPr id="26" name="text_536"/>
+          <p:cNvPr id="28" name="text_538"/>
           <p:cNvSpPr txBox="1"/>
           <p:nvPr/>
         </p:nvSpPr>
@@ -20460,7 +20544,7 @@
       </p:sp>
       <p:pic>
         <p:nvPicPr>
-          <p:cNvPr id="27" name="icon_537" descr="preencoded.png">    </p:cNvPr>
+          <p:cNvPr id="29" name="icon_539" descr="preencoded.png">    </p:cNvPr>
           <p:cNvPicPr>
             <a:picLocks noChangeAspect="1"/>
           </p:cNvPicPr>
@@ -20484,7 +20568,7 @@
       </p:pic>
       <p:sp>
         <p:nvSpPr>
-          <p:cNvPr id="28" name="text_538"/>
+          <p:cNvPr id="30" name="text_540"/>
           <p:cNvSpPr txBox="1"/>
           <p:nvPr/>
         </p:nvSpPr>
@@ -20520,7 +20604,7 @@
       </p:sp>
       <p:pic>
         <p:nvPicPr>
-          <p:cNvPr id="29" name="icon_539" descr="preencoded.png">    </p:cNvPr>
+          <p:cNvPr id="31" name="icon_541" descr="preencoded.png">    </p:cNvPr>
           <p:cNvPicPr>
             <a:picLocks noChangeAspect="1"/>
           </p:cNvPicPr>
@@ -20544,7 +20628,7 @@
       </p:pic>
       <p:sp>
         <p:nvSpPr>
-          <p:cNvPr id="30" name="text_540"/>
+          <p:cNvPr id="32" name="text_542"/>
           <p:cNvSpPr txBox="1"/>
           <p:nvPr/>
         </p:nvSpPr>
@@ -20591,7 +20675,7 @@
       </p:sp>
       <p:pic>
         <p:nvPicPr>
-          <p:cNvPr id="31" name="icon_541" descr="preencoded.png">    </p:cNvPr>
+          <p:cNvPr id="33" name="icon_543" descr="preencoded.png">    </p:cNvPr>
           <p:cNvPicPr>
             <a:picLocks noChangeAspect="1"/>
           </p:cNvPicPr>
@@ -20615,7 +20699,7 @@
       </p:pic>
       <p:sp>
         <p:nvSpPr>
-          <p:cNvPr id="32" name="text_542"/>
+          <p:cNvPr id="34" name="text_544"/>
           <p:cNvSpPr txBox="1"/>
           <p:nvPr/>
         </p:nvSpPr>
@@ -20662,7 +20746,7 @@
       </p:sp>
       <p:pic>
         <p:nvPicPr>
-          <p:cNvPr id="33" name="icon_543" descr="preencoded.png">    </p:cNvPr>
+          <p:cNvPr id="35" name="icon_545" descr="preencoded.png">    </p:cNvPr>
           <p:cNvPicPr>
             <a:picLocks noChangeAspect="1"/>
           </p:cNvPicPr>
@@ -20686,7 +20770,7 @@
       </p:pic>
       <p:sp>
         <p:nvSpPr>
-          <p:cNvPr id="34" name="text_544"/>
+          <p:cNvPr id="36" name="text_546"/>
           <p:cNvSpPr txBox="1"/>
           <p:nvPr/>
         </p:nvSpPr>
@@ -20733,7 +20817,7 @@
       </p:sp>
       <p:pic>
         <p:nvPicPr>
-          <p:cNvPr id="35" name="icon_545" descr="preencoded.png">    </p:cNvPr>
+          <p:cNvPr id="37" name="icon_547" descr="preencoded.png">    </p:cNvPr>
           <p:cNvPicPr>
             <a:picLocks noChangeAspect="1"/>
           </p:cNvPicPr>
@@ -20757,7 +20841,7 @@
       </p:pic>
       <p:sp>
         <p:nvSpPr>
-          <p:cNvPr id="36" name="text_546"/>
+          <p:cNvPr id="38" name="text_548"/>
           <p:cNvSpPr txBox="1"/>
           <p:nvPr/>
         </p:nvSpPr>
@@ -20804,7 +20888,7 @@
       </p:sp>
       <p:pic>
         <p:nvPicPr>
-          <p:cNvPr id="37" name="icon_547" descr="preencoded.png">    </p:cNvPr>
+          <p:cNvPr id="39" name="icon_549" descr="preencoded.png">    </p:cNvPr>
           <p:cNvPicPr>
             <a:picLocks noChangeAspect="1"/>
           </p:cNvPicPr>
@@ -20828,7 +20912,7 @@
       </p:pic>
       <p:sp>
         <p:nvSpPr>
-          <p:cNvPr id="38" name="text_548"/>
+          <p:cNvPr id="40" name="text_550"/>
           <p:cNvSpPr txBox="1"/>
           <p:nvPr/>
         </p:nvSpPr>
@@ -20875,7 +20959,7 @@
       </p:sp>
       <p:pic>
         <p:nvPicPr>
-          <p:cNvPr id="39" name="icon_549" descr="preencoded.png">    </p:cNvPr>
+          <p:cNvPr id="41" name="icon_551" descr="preencoded.png">    </p:cNvPr>
           <p:cNvPicPr>
             <a:picLocks noChangeAspect="1"/>
           </p:cNvPicPr>
@@ -20899,7 +20983,7 @@
       </p:pic>
       <p:sp>
         <p:nvSpPr>
-          <p:cNvPr id="40" name="text_550"/>
+          <p:cNvPr id="42" name="text_552"/>
           <p:cNvSpPr txBox="1"/>
           <p:nvPr/>
         </p:nvSpPr>
@@ -20946,7 +21030,7 @@
       </p:sp>
       <p:sp>
         <p:nvSpPr>
-          <p:cNvPr id="41" name="text_551"/>
+          <p:cNvPr id="43" name="text_553"/>
           <p:cNvSpPr txBox="1"/>
           <p:nvPr/>
         </p:nvSpPr>
@@ -20974,7 +21058,7 @@
       </p:sp>
       <p:sp>
         <p:nvSpPr>
-          <p:cNvPr id="42" name="text_552"/>
+          <p:cNvPr id="44" name="text_554"/>
           <p:cNvSpPr txBox="1"/>
           <p:nvPr/>
         </p:nvSpPr>
@@ -21118,7 +21202,7 @@
       </p:sp>
       <p:sp>
         <p:nvSpPr>
-          <p:cNvPr id="4" name="chip_553"/>
+          <p:cNvPr id="4" name="chip_555"/>
           <p:cNvSpPr txBox="1"/>
           <p:nvPr/>
         </p:nvSpPr>
@@ -21158,7 +21242,7 @@
       </p:sp>
       <p:sp>
         <p:nvSpPr>
-          <p:cNvPr id="5" name="chip_554"/>
+          <p:cNvPr id="5" name="chip_556"/>
           <p:cNvSpPr txBox="1"/>
           <p:nvPr/>
         </p:nvSpPr>
@@ -21198,7 +21282,7 @@
       </p:sp>
       <p:sp>
         <p:nvSpPr>
-          <p:cNvPr id="6" name="card_555"/>
+          <p:cNvPr id="6" name="card_557"/>
           <p:cNvSpPr/>
           <p:nvPr/>
         </p:nvSpPr>
@@ -21220,7 +21304,7 @@
       </p:sp>
       <p:sp>
         <p:nvSpPr>
-          <p:cNvPr id="7" name="chip_556"/>
+          <p:cNvPr id="7" name="chip_558"/>
           <p:cNvSpPr txBox="1"/>
           <p:nvPr/>
         </p:nvSpPr>
@@ -21260,7 +21344,7 @@
       </p:sp>
       <p:sp>
         <p:nvSpPr>
-          <p:cNvPr id="8" name="text_557"/>
+          <p:cNvPr id="8" name="text_559"/>
           <p:cNvSpPr txBox="1"/>
           <p:nvPr/>
         </p:nvSpPr>
@@ -21296,7 +21380,7 @@
       </p:sp>
       <p:sp>
         <p:nvSpPr>
-          <p:cNvPr id="9" name="text_558"/>
+          <p:cNvPr id="9" name="text_560"/>
           <p:cNvSpPr txBox="1"/>
           <p:nvPr/>
         </p:nvSpPr>
@@ -21324,7 +21408,7 @@
                   <a:schemeClr val="accent6"/>
                 </a:solidFill>
               </a:rPr>
-              <a:t>'로그인 성공_자동' 테스트케이스를 ScratchBook에서 검증 실행해줘. 끝나면 스텝별 통과/실패를 표로 보여줘.</a:t>
+              <a:t>워크스페이스를 저장한 다음 '로그인 성공_자동' 테스트케이스를 ScratchBook에서 검증 실행해줘. 끝나면 스텝별 통과/실패를 표로 보여줘.</a:t>
             </a:r>
             <a:endParaRPr lang="en-US" sz="1300" dirty="0"/>
           </a:p>
@@ -21332,7 +21416,7 @@
       </p:sp>
       <p:sp>
         <p:nvSpPr>
-          <p:cNvPr id="10" name="chip_559"/>
+          <p:cNvPr id="10" name="chip_561"/>
           <p:cNvSpPr txBox="1"/>
           <p:nvPr/>
         </p:nvSpPr>
@@ -21372,7 +21456,7 @@
       </p:sp>
       <p:sp>
         <p:nvSpPr>
-          <p:cNvPr id="11" name="line_560"/>
+          <p:cNvPr id="11" name="line_562"/>
           <p:cNvSpPr/>
           <p:nvPr/>
         </p:nvSpPr>
@@ -21396,7 +21480,7 @@
       </p:sp>
       <p:sp>
         <p:nvSpPr>
-          <p:cNvPr id="12" name="card_561"/>
+          <p:cNvPr id="12" name="card_563"/>
           <p:cNvSpPr/>
           <p:nvPr/>
         </p:nvSpPr>
@@ -21418,7 +21502,7 @@
       </p:sp>
       <p:sp>
         <p:nvSpPr>
-          <p:cNvPr id="13" name="chip_562"/>
+          <p:cNvPr id="13" name="chip_564"/>
           <p:cNvSpPr txBox="1"/>
           <p:nvPr/>
         </p:nvSpPr>
@@ -21458,7 +21542,7 @@
       </p:sp>
       <p:sp>
         <p:nvSpPr>
-          <p:cNvPr id="14" name="text_563"/>
+          <p:cNvPr id="14" name="text_565"/>
           <p:cNvSpPr txBox="1"/>
           <p:nvPr/>
         </p:nvSpPr>
@@ -21494,7 +21578,7 @@
       </p:sp>
       <p:sp>
         <p:nvSpPr>
-          <p:cNvPr id="15" name="text_564"/>
+          <p:cNvPr id="15" name="text_566"/>
           <p:cNvSpPr txBox="1"/>
           <p:nvPr/>
         </p:nvSpPr>
@@ -21522,7 +21606,7 @@
                   <a:schemeClr val="accent6"/>
                 </a:solidFill>
               </a:rPr>
-              <a:t>같은 테스트케이스에서 Account의 Verify 값을 wrong@example.com 으로 바꾸고 다시 검증 실행해줘.</a:t>
+              <a:t>같은 테스트케이스에서 Account의 Verify 값을 wrong@example.com 으로 바꾸고, 저장한 다음 다시 검증 실행해줘.</a:t>
             </a:r>
             <a:endParaRPr lang="en-US" sz="1300" dirty="0"/>
           </a:p>
@@ -21530,7 +21614,7 @@
       </p:sp>
       <p:sp>
         <p:nvSpPr>
-          <p:cNvPr id="16" name="chip_565"/>
+          <p:cNvPr id="16" name="chip_567"/>
           <p:cNvSpPr txBox="1"/>
           <p:nvPr/>
         </p:nvSpPr>
@@ -21570,7 +21654,7 @@
       </p:sp>
       <p:sp>
         <p:nvSpPr>
-          <p:cNvPr id="17" name="line_566"/>
+          <p:cNvPr id="17" name="line_568"/>
           <p:cNvSpPr/>
           <p:nvPr/>
         </p:nvSpPr>
@@ -21594,7 +21678,7 @@
       </p:sp>
       <p:sp>
         <p:nvSpPr>
-          <p:cNvPr id="18" name="card_567"/>
+          <p:cNvPr id="18" name="card_569"/>
           <p:cNvSpPr/>
           <p:nvPr/>
         </p:nvSpPr>
@@ -21616,7 +21700,7 @@
       </p:sp>
       <p:sp>
         <p:nvSpPr>
-          <p:cNvPr id="19" name="chip_568"/>
+          <p:cNvPr id="19" name="chip_570"/>
           <p:cNvSpPr txBox="1"/>
           <p:nvPr/>
         </p:nvSpPr>
@@ -21656,7 +21740,7 @@
       </p:sp>
       <p:sp>
         <p:nvSpPr>
-          <p:cNvPr id="20" name="text_569"/>
+          <p:cNvPr id="20" name="text_571"/>
           <p:cNvSpPr txBox="1"/>
           <p:nvPr/>
         </p:nvSpPr>
@@ -21692,7 +21776,7 @@
       </p:sp>
       <p:sp>
         <p:nvSpPr>
-          <p:cNvPr id="21" name="text_570"/>
+          <p:cNvPr id="21" name="text_572"/>
           <p:cNvSpPr txBox="1"/>
           <p:nvPr/>
         </p:nvSpPr>
@@ -21728,7 +21812,7 @@
       </p:sp>
       <p:sp>
         <p:nvSpPr>
-          <p:cNvPr id="22" name="chip_571"/>
+          <p:cNvPr id="22" name="chip_573"/>
           <p:cNvSpPr txBox="1"/>
           <p:nvPr/>
         </p:nvSpPr>
@@ -21768,7 +21852,7 @@
       </p:sp>
       <p:sp>
         <p:nvSpPr>
-          <p:cNvPr id="23" name="line_572"/>
+          <p:cNvPr id="23" name="line_574"/>
           <p:cNvSpPr/>
           <p:nvPr/>
         </p:nvSpPr>
@@ -21792,7 +21876,7 @@
       </p:sp>
       <p:sp>
         <p:nvSpPr>
-          <p:cNvPr id="24" name="card_573"/>
+          <p:cNvPr id="24" name="card_575"/>
           <p:cNvSpPr/>
           <p:nvPr/>
         </p:nvSpPr>
@@ -21814,7 +21898,7 @@
       </p:sp>
       <p:sp>
         <p:nvSpPr>
-          <p:cNvPr id="25" name="chip_574"/>
+          <p:cNvPr id="25" name="chip_576"/>
           <p:cNvSpPr txBox="1"/>
           <p:nvPr/>
         </p:nvSpPr>
@@ -21854,7 +21938,7 @@
       </p:sp>
       <p:sp>
         <p:nvSpPr>
-          <p:cNvPr id="26" name="text_575"/>
+          <p:cNvPr id="26" name="text_577"/>
           <p:cNvSpPr txBox="1"/>
           <p:nvPr/>
         </p:nvSpPr>
@@ -21890,7 +21974,7 @@
       </p:sp>
       <p:sp>
         <p:nvSpPr>
-          <p:cNvPr id="27" name="text_576"/>
+          <p:cNvPr id="27" name="text_578"/>
           <p:cNvSpPr txBox="1"/>
           <p:nvPr/>
         </p:nvSpPr>
@@ -21918,7 +22002,7 @@
                   <a:schemeClr val="accent6"/>
                 </a:solidFill>
               </a:rPr>
-              <a:t>Verify 값을 원래 [실습 이메일]로 되돌리고 다시 검증 실행해줘. 통과하면 결과 표를 보여줘.</a:t>
+              <a:t>Verify 값을 원래 [실습 이메일]로 되돌리고, 저장한 다음 다시 검증 실행해줘. 통과하면 결과 표를 보여줘.</a:t>
             </a:r>
             <a:endParaRPr lang="en-US" sz="1300" dirty="0"/>
           </a:p>
@@ -21926,7 +22010,7 @@
       </p:sp>
       <p:sp>
         <p:nvSpPr>
-          <p:cNvPr id="28" name="chip_577"/>
+          <p:cNvPr id="28" name="chip_579"/>
           <p:cNvSpPr txBox="1"/>
           <p:nvPr/>
         </p:nvSpPr>
@@ -21966,7 +22050,7 @@
       </p:sp>
       <p:pic>
         <p:nvPicPr>
-          <p:cNvPr id="29" name="icon_578" descr="preencoded.png">    </p:cNvPr>
+          <p:cNvPr id="29" name="icon_580" descr="preencoded.png">    </p:cNvPr>
           <p:cNvPicPr>
             <a:picLocks noChangeAspect="1"/>
           </p:cNvPicPr>
@@ -21990,7 +22074,7 @@
       </p:pic>
       <p:sp>
         <p:nvSpPr>
-          <p:cNvPr id="30" name="text_579"/>
+          <p:cNvPr id="30" name="text_581"/>
           <p:cNvSpPr txBox="1"/>
           <p:nvPr/>
         </p:nvSpPr>
@@ -22026,7 +22110,7 @@
       </p:sp>
       <p:pic>
         <p:nvPicPr>
-          <p:cNvPr id="31" name="icon_580" descr="preencoded.png">    </p:cNvPr>
+          <p:cNvPr id="31" name="icon_582" descr="preencoded.png">    </p:cNvPr>
           <p:cNvPicPr>
             <a:picLocks noChangeAspect="1"/>
           </p:cNvPicPr>
@@ -22050,7 +22134,7 @@
       </p:pic>
       <p:sp>
         <p:nvSpPr>
-          <p:cNvPr id="32" name="text_581"/>
+          <p:cNvPr id="32" name="text_583"/>
           <p:cNvSpPr txBox="1"/>
           <p:nvPr/>
         </p:nvSpPr>
@@ -22086,7 +22170,7 @@
       </p:sp>
       <p:sp>
         <p:nvSpPr>
-          <p:cNvPr id="33" name="text_582"/>
+          <p:cNvPr id="33" name="text_584"/>
           <p:cNvSpPr txBox="1"/>
           <p:nvPr/>
         </p:nvSpPr>
@@ -22114,7 +22198,7 @@
                   <a:schemeClr val="accent6"/>
                 </a:solidFill>
               </a:rPr>
-              <a:t>AI가 쓰는 도구: execute_test_suite (is_validation_run=true), execute_test_suite_status, set_attribute</a:t>
+              <a:t>AI가 쓰는 도구: save_workspace, execute_test_suite (is_validation_run=true), execute_test_suite_status, set_attribute</a:t>
             </a:r>
             <a:endParaRPr lang="en-US" sz="1100" dirty="0"/>
           </a:p>
@@ -22230,7 +22314,7 @@
       </p:sp>
       <p:sp>
         <p:nvSpPr>
-          <p:cNvPr id="4" name="chip_583"/>
+          <p:cNvPr id="4" name="chip_585"/>
           <p:cNvSpPr txBox="1"/>
           <p:nvPr/>
         </p:nvSpPr>
@@ -22270,7 +22354,7 @@
       </p:sp>
       <p:sp>
         <p:nvSpPr>
-          <p:cNvPr id="5" name="chip_584"/>
+          <p:cNvPr id="5" name="chip_586"/>
           <p:cNvSpPr txBox="1"/>
           <p:nvPr/>
         </p:nvSpPr>
@@ -22310,7 +22394,7 @@
       </p:sp>
       <p:sp>
         <p:nvSpPr>
-          <p:cNvPr id="6" name="prompt_585"/>
+          <p:cNvPr id="6" name="prompt_587"/>
           <p:cNvSpPr/>
           <p:nvPr/>
         </p:nvSpPr>
@@ -22339,7 +22423,7 @@
       </p:sp>
       <p:sp>
         <p:nvSpPr>
-          <p:cNvPr id="7" name="chip_586"/>
+          <p:cNvPr id="7" name="chip_588"/>
           <p:cNvSpPr txBox="1"/>
           <p:nvPr/>
         </p:nvSpPr>
@@ -22379,7 +22463,7 @@
       </p:sp>
       <p:sp>
         <p:nvSpPr>
-          <p:cNvPr id="8" name="text_587"/>
+          <p:cNvPr id="8" name="text_589"/>
           <p:cNvSpPr txBox="1"/>
           <p:nvPr/>
         </p:nvSpPr>
@@ -22418,7 +22502,7 @@
       </p:sp>
       <p:graphicFrame>
         <p:nvGraphicFramePr>
-          <p:cNvPr id="23" name="table_588"/>
+          <p:cNvPr id="23" name="table_590"/>
           <p:cNvGraphicFramePr>
             <a:graphicFrameLocks noGrp="1"/>
           </p:cNvGraphicFramePr>
@@ -22510,7 +22594,7 @@
                             <a:schemeClr val="bg1"/>
                           </a:solidFill>
                         </a:rPr>
-                        <a:t>작업 끝에 하는 일</a:t>
+                        <a:t>시작과 끝에 하는 일</a:t>
                       </a:r>
                       <a:endParaRPr lang="en-US" sz="1200" dirty="0"/>
                     </a:p>
@@ -22637,7 +22721,7 @@
                           <a:ea typeface="Consolas" pitchFamily="34" charset="-122"/>
                           <a:cs typeface="Consolas" pitchFamily="34" charset="-120"/>
                         </a:rPr>
-                        <a:t>save_workspace</a:t>
+                        <a:t>끝: save_workspace</a:t>
                       </a:r>
                       <a:endParaRPr lang="en-US" sz="1200" dirty="0">
                         <a:latin typeface="Consolas" charset="0"/>
@@ -22765,7 +22849,28 @@
                           <a:ea typeface="Consolas" pitchFamily="34" charset="-122"/>
                           <a:cs typeface="Consolas" pitchFamily="34" charset="-120"/>
                         </a:rPr>
-                        <a:t>update_all → 편집 → save_workspace → check_in_all</a:t>
+                        <a:t>시작: update_all → Checkout</a:t>
+                      </a:r>
+                      <a:endParaRPr lang="en-US" sz="1200" dirty="0">
+                        <a:latin typeface="Consolas" charset="0"/>
+                        <a:ea typeface="Consolas" charset="0"/>
+                        <a:cs typeface="Consolas" charset="0"/>
+                      </a:endParaRPr>
+                    </a:p>
+                    <a:p>
+                      <a:pPr indent="0" marL="0">
+                        <a:buNone/>
+                      </a:pPr>
+                      <a:r>
+                        <a:rPr lang="en-US" sz="1200" dirty="0">
+                          <a:solidFill>
+                            <a:schemeClr val="tx1"/>
+                          </a:solidFill>
+                          <a:latin typeface="Consolas" pitchFamily="34" charset="0"/>
+                          <a:ea typeface="Consolas" pitchFamily="34" charset="-122"/>
+                          <a:cs typeface="Consolas" pitchFamily="34" charset="-120"/>
+                        </a:rPr>
+                        <a:t>끝: save_workspace → check_in_all</a:t>
                       </a:r>
                       <a:endParaRPr lang="en-US" sz="1200" dirty="0">
                         <a:latin typeface="Consolas" charset="0"/>
@@ -22820,7 +22925,7 @@
       </p:graphicFrame>
       <p:sp>
         <p:nvSpPr>
-          <p:cNvPr id="10" name="card_589"/>
+          <p:cNvPr id="10" name="card_591"/>
           <p:cNvSpPr/>
           <p:nvPr/>
         </p:nvSpPr>
@@ -22842,7 +22947,7 @@
       </p:sp>
       <p:sp>
         <p:nvSpPr>
-          <p:cNvPr id="11" name="text_590"/>
+          <p:cNvPr id="11" name="text_592"/>
           <p:cNvSpPr txBox="1"/>
           <p:nvPr/>
         </p:nvSpPr>
@@ -22878,7 +22983,7 @@
       </p:sp>
       <p:sp>
         <p:nvSpPr>
-          <p:cNvPr id="12" name="text_591"/>
+          <p:cNvPr id="12" name="text_593"/>
           <p:cNvSpPr txBox="1"/>
           <p:nvPr/>
         </p:nvSpPr>
@@ -22906,7 +23011,7 @@
                   <a:schemeClr val="tx1"/>
                 </a:solidFill>
               </a:rPr>
-              <a:t>바뀐 객체 목록을 먼저 보여줘. 내가 확인하면 저장하고 체크인해줘. 체크인 코멘트는 'MCP 실습: 로그인 테스트 추가'로 남겨줘.</a:t>
+              <a:t>이번 대화에서 체크아웃하거나 바꾼 객체 목록을 먼저 보여줘. 체크인은 내가 체크아웃한 객체 전부에 적용되니까, 내가 목록을 확인하면 저장하고 체크인해줘. 체크인 코멘트는 'MCP 실습: 로그인 테스트 추가'로 남겨줘.</a:t>
             </a:r>
             <a:endParaRPr lang="en-US" sz="1200" dirty="0"/>
           </a:p>
@@ -22914,7 +23019,7 @@
       </p:sp>
       <p:sp>
         <p:nvSpPr>
-          <p:cNvPr id="13" name="text_592"/>
+          <p:cNvPr id="13" name="text_594"/>
           <p:cNvSpPr txBox="1"/>
           <p:nvPr/>
         </p:nvSpPr>
@@ -22950,7 +23055,7 @@
       </p:sp>
       <p:graphicFrame>
         <p:nvGraphicFramePr>
-          <p:cNvPr id="45" name="table_593"/>
+          <p:cNvPr id="45" name="table_595"/>
           <p:cNvGraphicFramePr>
             <a:graphicFrameLocks noGrp="1"/>
           </p:cNvGraphicFramePr>
@@ -22971,8 +23076,8 @@
             <a:tbl>
               <a:tblPr/>
               <a:tblGrid>
-                <a:gridCol w="1920240"/>
-                <a:gridCol w="3730752"/>
+                <a:gridCol w="1828800"/>
+                <a:gridCol w="3822192"/>
               </a:tblGrid>
               <a:tr h="0">
                 <a:tc>
@@ -22984,14 +23089,14 @@
                         <a:buNone/>
                       </a:pPr>
                       <a:r>
-                        <a:rPr lang="en-US" sz="1150" b="1" dirty="0">
+                        <a:rPr lang="en-US" sz="1100" b="1" dirty="0">
                           <a:solidFill>
                             <a:schemeClr val="bg1"/>
                           </a:solidFill>
                         </a:rPr>
                         <a:t>증상</a:t>
                       </a:r>
-                      <a:endParaRPr lang="en-US" sz="1150" dirty="0"/>
+                      <a:endParaRPr lang="en-US" sz="1100" dirty="0"/>
                     </a:p>
                   </a:txBody>
                   <a:tcPr marL="76200" marR="76200" marT="50800" marB="50800" anchor="ctr">
@@ -23045,14 +23150,14 @@
                         <a:buNone/>
                       </a:pPr>
                       <a:r>
-                        <a:rPr lang="en-US" sz="1150" b="1" dirty="0">
+                        <a:rPr lang="en-US" sz="1100" b="1" dirty="0">
                           <a:solidFill>
                             <a:schemeClr val="bg1"/>
                           </a:solidFill>
                         </a:rPr>
                         <a:t>이렇게 한다</a:t>
                       </a:r>
-                      <a:endParaRPr lang="en-US" sz="1150" dirty="0"/>
+                      <a:endParaRPr lang="en-US" sz="1100" dirty="0"/>
                     </a:p>
                   </a:txBody>
                   <a:tcPr marL="76200" marR="76200" marT="50800" marB="50800" anchor="ctr">
@@ -23108,14 +23213,14 @@
                         <a:buNone/>
                       </a:pPr>
                       <a:r>
-                        <a:rPr lang="en-US" sz="1150" b="1" dirty="0">
+                        <a:rPr lang="en-US" sz="1100" b="1" dirty="0">
                           <a:solidFill>
                             <a:schemeClr val="tx1"/>
                           </a:solidFill>
                         </a:rPr>
                         <a:t>연결 거부, 서버 응답 없음</a:t>
                       </a:r>
-                      <a:endParaRPr lang="en-US" sz="1150" dirty="0"/>
+                      <a:endParaRPr lang="en-US" sz="1100" dirty="0"/>
                     </a:p>
                   </a:txBody>
                   <a:tcPr marL="76200" marR="76200" marT="50800" marB="50800" anchor="ctr">
@@ -23169,14 +23274,14 @@
                         <a:buNone/>
                       </a:pPr>
                       <a:r>
-                        <a:rPr lang="en-US" sz="1150" dirty="0">
+                        <a:rPr lang="en-US" sz="1100" dirty="0">
                           <a:solidFill>
                             <a:schemeClr val="tx1"/>
                           </a:solidFill>
                         </a:rPr>
                         <a:t>Commander 실행 → 워크스페이스 열기 → 포트 46248 확인 (디버그 빌드는 8080, 직접 바꿨다면 그 값)</a:t>
                       </a:r>
-                      <a:endParaRPr lang="en-US" sz="1150" dirty="0"/>
+                      <a:endParaRPr lang="en-US" sz="1100" dirty="0"/>
                     </a:p>
                   </a:txBody>
                   <a:tcPr marL="76200" marR="76200" marT="50800" marB="50800" anchor="ctr">
@@ -23232,14 +23337,14 @@
                         <a:buNone/>
                       </a:pPr>
                       <a:r>
-                        <a:rPr lang="en-US" sz="1150" b="1" dirty="0">
+                        <a:rPr lang="en-US" sz="1100" b="1" dirty="0">
                           <a:solidFill>
                             <a:schemeClr val="tx1"/>
                           </a:solidFill>
                         </a:rPr>
                         <a:t>"Unknown task ..." 응답</a:t>
                       </a:r>
-                      <a:endParaRPr lang="en-US" sz="1150" dirty="0"/>
+                      <a:endParaRPr lang="en-US" sz="1100" dirty="0"/>
                     </a:p>
                   </a:txBody>
                   <a:tcPr marL="76200" marR="76200" marT="50800" marB="50800" anchor="ctr">
@@ -23293,14 +23398,14 @@
                         <a:buNone/>
                       </a:pPr>
                       <a:r>
-                        <a:rPr lang="en-US" sz="1150" dirty="0">
+                        <a:rPr lang="en-US" sz="1100" dirty="0">
                           <a:solidFill>
                             <a:schemeClr val="tx1"/>
                           </a:solidFill>
                         </a:rPr>
-                        <a:t>"상위 폴더를 Checkout 한 다음 다시 시도해줘"</a:t>
+                        <a:t>"작업 목록을 다시 보고 정확한 이름으로 실행해줘". 멀티 유저라면 대상을 먼저 Checkout (자식 생성·삭제는 상위 폴더)</a:t>
                       </a:r>
-                      <a:endParaRPr lang="en-US" sz="1150" dirty="0"/>
+                      <a:endParaRPr lang="en-US" sz="1100" dirty="0"/>
                     </a:p>
                   </a:txBody>
                   <a:tcPr marL="76200" marR="76200" marT="50800" marB="50800" anchor="ctr">
@@ -23356,14 +23461,14 @@
                         <a:buNone/>
                       </a:pPr>
                       <a:r>
-                        <a:rPr lang="en-US" sz="1150" b="1" dirty="0">
+                        <a:rPr lang="en-US" sz="1100" b="1" dirty="0">
                           <a:solidFill>
                             <a:schemeClr val="tx1"/>
                           </a:solidFill>
                         </a:rPr>
                         <a:t>모듈을 못 찾음</a:t>
                       </a:r>
-                      <a:endParaRPr lang="en-US" sz="1150" dirty="0"/>
+                      <a:endParaRPr lang="en-US" sz="1100" dirty="0"/>
                     </a:p>
                   </a:txBody>
                   <a:tcPr marL="76200" marR="76200" marT="50800" marB="50800" anchor="ctr">
@@ -23417,14 +23522,14 @@
                         <a:buNone/>
                       </a:pPr>
                       <a:r>
-                        <a:rPr lang="en-US" sz="1150" dirty="0">
+                        <a:rPr lang="en-US" sz="1100" dirty="0">
                           <a:solidFill>
                             <a:schemeClr val="tx1"/>
                           </a:solidFill>
                         </a:rPr>
                         <a:t>모듈 폴더 경로를 알려 준다. 없으면 XScan으로 스캔 후 재요청</a:t>
                       </a:r>
-                      <a:endParaRPr lang="en-US" sz="1150" dirty="0"/>
+                      <a:endParaRPr lang="en-US" sz="1100" dirty="0"/>
                     </a:p>
                   </a:txBody>
                   <a:tcPr marL="76200" marR="76200" marT="50800" marB="50800" anchor="ctr">
@@ -23480,14 +23585,14 @@
                         <a:buNone/>
                       </a:pPr>
                       <a:r>
-                        <a:rPr lang="en-US" sz="1150" b="1" dirty="0">
+                        <a:rPr lang="en-US" sz="1100" b="1" dirty="0">
                           <a:solidFill>
                             <a:schemeClr val="tx1"/>
                           </a:solidFill>
                         </a:rPr>
                         <a:t>Commander가 대화상자를 띄우고 멈춤</a:t>
                       </a:r>
-                      <a:endParaRPr lang="en-US" sz="1150" dirty="0"/>
+                      <a:endParaRPr lang="en-US" sz="1100" dirty="0"/>
                     </a:p>
                   </a:txBody>
                   <a:tcPr marL="76200" marR="76200" marT="50800" marB="50800" anchor="ctr">
@@ -23541,14 +23646,14 @@
                         <a:buNone/>
                       </a:pPr>
                       <a:r>
-                        <a:rPr lang="en-US" sz="1150" dirty="0">
+                        <a:rPr lang="en-US" sz="1100" dirty="0">
                           <a:solidFill>
                             <a:schemeClr val="tx1"/>
                           </a:solidFill>
                         </a:rPr>
                         <a:t>대화상자 닫기 → "속성 변경(set_attribute)으로 해줘". 스킬팩 설치로 예방</a:t>
                       </a:r>
-                      <a:endParaRPr lang="en-US" sz="1150" dirty="0"/>
+                      <a:endParaRPr lang="en-US" sz="1100" dirty="0"/>
                     </a:p>
                   </a:txBody>
                   <a:tcPr marL="76200" marR="76200" marT="50800" marB="50800" anchor="ctr">
@@ -23604,14 +23709,14 @@
                         <a:buNone/>
                       </a:pPr>
                       <a:r>
-                        <a:rPr lang="en-US" sz="1150" b="1" dirty="0">
+                        <a:rPr lang="en-US" sz="1100" b="1" dirty="0">
                           <a:solidFill>
                             <a:schemeClr val="tx1"/>
                           </a:solidFill>
                         </a:rPr>
                         <a:t>실행 결과가 안 돌아옴, 시간 초과</a:t>
                       </a:r>
-                      <a:endParaRPr lang="en-US" sz="1150" dirty="0"/>
+                      <a:endParaRPr lang="en-US" sz="1100" dirty="0"/>
                     </a:p>
                   </a:txBody>
                   <a:tcPr marL="76200" marR="76200" marT="50800" marB="50800" anchor="ctr">
@@ -23665,14 +23770,14 @@
                         <a:buNone/>
                       </a:pPr>
                       <a:r>
-                        <a:rPr lang="en-US" sz="1150" dirty="0">
+                        <a:rPr lang="en-US" sz="1100" dirty="0">
                           <a:solidFill>
                             <a:schemeClr val="tx1"/>
                           </a:solidFill>
                         </a:rPr>
                         <a:t>재실행하지 말고 "마지막 실행 결과를 확인해줘"</a:t>
                       </a:r>
-                      <a:endParaRPr lang="en-US" sz="1150" dirty="0"/>
+                      <a:endParaRPr lang="en-US" sz="1100" dirty="0"/>
                     </a:p>
                   </a:txBody>
                   <a:tcPr marL="76200" marR="76200" marT="50800" marB="50800" anchor="ctr">
@@ -23724,18 +23829,18 @@
       </p:graphicFrame>
       <p:sp>
         <p:nvSpPr>
-          <p:cNvPr id="15" name="card_594"/>
+          <p:cNvPr id="15" name="card_596"/>
           <p:cNvSpPr/>
           <p:nvPr/>
         </p:nvSpPr>
         <p:spPr>
           <a:xfrm>
-            <a:off x="5989320" y="4892040"/>
-            <a:ext cx="5650992" cy="1280160"/>
+            <a:off x="5989320" y="5349240"/>
+            <a:ext cx="5650992" cy="822960"/>
           </a:xfrm>
           <a:prstGeom prst="roundRect">
             <a:avLst>
-              <a:gd name="adj" fmla="val 7143"/>
+              <a:gd name="adj" fmla="val 11111"/>
             </a:avLst>
           </a:prstGeom>
           <a:solidFill>
@@ -23748,7 +23853,7 @@
       </p:sp>
       <p:pic>
         <p:nvPicPr>
-          <p:cNvPr id="16" name="icon_595" descr="preencoded.png">    </p:cNvPr>
+          <p:cNvPr id="16" name="icon_597" descr="preencoded.png">    </p:cNvPr>
           <p:cNvPicPr>
             <a:picLocks noChangeAspect="1"/>
           </p:cNvPicPr>
@@ -23762,7 +23867,7 @@
         </p:blipFill>
         <p:spPr>
           <a:xfrm>
-            <a:off x="6217920" y="5120640"/>
+            <a:off x="6172200" y="5559552"/>
             <a:ext cx="384048" cy="384048"/>
           </a:xfrm>
           <a:prstGeom prst="rect">
@@ -23772,14 +23877,14 @@
       </p:pic>
       <p:sp>
         <p:nvSpPr>
-          <p:cNvPr id="17" name="text_596"/>
-          <p:cNvSpPr txBox="1"/>
-          <p:nvPr/>
-        </p:nvSpPr>
-        <p:spPr>
-          <a:xfrm>
-            <a:off x="6766560" y="4983480"/>
-            <a:ext cx="4709160" cy="1097280"/>
+          <p:cNvPr id="17" name="text_598"/>
+          <p:cNvSpPr txBox="1"/>
+          <p:nvPr/>
+        </p:nvSpPr>
+        <p:spPr>
+          <a:xfrm>
+            <a:off x="6693408" y="5349240"/>
+            <a:ext cx="4800600" cy="822960"/>
           </a:xfrm>
           <a:prstGeom prst="rect">
             <a:avLst/>
@@ -23795,14 +23900,14 @@
               <a:buNone/>
             </a:pPr>
             <a:r>
-              <a:rPr lang="en-US" sz="1300" dirty="0">
+              <a:rPr lang="en-US" sz="1250" dirty="0">
                 <a:solidFill>
                   <a:schemeClr val="tx1"/>
                 </a:solidFill>
               </a:rPr>
-              <a:t>그래도 안 되면 AI에게 받은 응답을 그대로 복사해 강사에게 보여 준다. 증상 8가지 전체는 워크북 부록 B.</a:t>
-            </a:r>
-            <a:endParaRPr lang="en-US" sz="1300" dirty="0"/>
+              <a:t>그래도 안 되면 AI 응답을 그대로 복사해 강사에게 보여 준다. 전체 8가지는 워크북 부록 B.</a:t>
+            </a:r>
+            <a:endParaRPr lang="en-US" sz="1250" dirty="0"/>
           </a:p>
         </p:txBody>
       </p:sp>
@@ -23984,7 +24089,7 @@
                   <a:schemeClr val="bg2"/>
                 </a:solidFill>
               </a:rPr>
-              <a:t>현업에서 많이 쓰는 여섯 가지와, 결과를 바꾸는 프롬프트 쓰는 법</a:t>
+              <a:t>업무에 써 볼 만한 여섯 가지와 프롬프트 쓰는 법</a:t>
             </a:r>
             <a:endParaRPr lang="en-US" sz="1800" dirty="0"/>
           </a:p>
@@ -24047,7 +24152,7 @@
                   <a:schemeClr val="tx2"/>
                 </a:solidFill>
               </a:rPr>
-              <a:t>현업에서 많이 쓰는 여섯 가지</a:t>
+              <a:t>업무에 써 볼 만한 여섯 가지</a:t>
             </a:r>
             <a:endParaRPr lang="en-US" sz="3200" dirty="0"/>
           </a:p>
@@ -24055,7 +24160,7 @@
       </p:sp>
       <p:sp>
         <p:nvSpPr>
-          <p:cNvPr id="4" name="card_597"/>
+          <p:cNvPr id="4" name="card_599"/>
           <p:cNvSpPr/>
           <p:nvPr/>
         </p:nvSpPr>
@@ -24089,7 +24194,7 @@
       </p:sp>
       <p:sp>
         <p:nvSpPr>
-          <p:cNvPr id="5" name="text_598"/>
+          <p:cNvPr id="5" name="text_600"/>
           <p:cNvSpPr txBox="1"/>
           <p:nvPr/>
         </p:nvSpPr>
@@ -24125,7 +24230,7 @@
       </p:sp>
       <p:sp>
         <p:nvSpPr>
-          <p:cNvPr id="6" name="text_599"/>
+          <p:cNvPr id="6" name="text_601"/>
           <p:cNvSpPr txBox="1"/>
           <p:nvPr/>
         </p:nvSpPr>
@@ -24161,7 +24266,7 @@
       </p:sp>
       <p:sp>
         <p:nvSpPr>
-          <p:cNvPr id="7" name="text_600"/>
+          <p:cNvPr id="7" name="text_602"/>
           <p:cNvSpPr txBox="1"/>
           <p:nvPr/>
         </p:nvSpPr>
@@ -24197,7 +24302,7 @@
       </p:sp>
       <p:sp>
         <p:nvSpPr>
-          <p:cNvPr id="8" name="line_601"/>
+          <p:cNvPr id="8" name="line_603"/>
           <p:cNvSpPr/>
           <p:nvPr/>
         </p:nvSpPr>
@@ -24220,7 +24325,7 @@
       </p:sp>
       <p:sp>
         <p:nvSpPr>
-          <p:cNvPr id="9" name="text_602"/>
+          <p:cNvPr id="9" name="text_604"/>
           <p:cNvSpPr txBox="1"/>
           <p:nvPr/>
         </p:nvSpPr>
@@ -24267,7 +24372,7 @@
       </p:sp>
       <p:sp>
         <p:nvSpPr>
-          <p:cNvPr id="10" name="chip_603"/>
+          <p:cNvPr id="10" name="chip_605"/>
           <p:cNvSpPr txBox="1"/>
           <p:nvPr/>
         </p:nvSpPr>
@@ -24307,7 +24412,7 @@
       </p:sp>
       <p:sp>
         <p:nvSpPr>
-          <p:cNvPr id="11" name="card_604"/>
+          <p:cNvPr id="11" name="card_606"/>
           <p:cNvSpPr/>
           <p:nvPr/>
         </p:nvSpPr>
@@ -24341,7 +24446,7 @@
       </p:sp>
       <p:sp>
         <p:nvSpPr>
-          <p:cNvPr id="12" name="text_605"/>
+          <p:cNvPr id="12" name="text_607"/>
           <p:cNvSpPr txBox="1"/>
           <p:nvPr/>
         </p:nvSpPr>
@@ -24377,7 +24482,7 @@
       </p:sp>
       <p:sp>
         <p:nvSpPr>
-          <p:cNvPr id="13" name="text_606"/>
+          <p:cNvPr id="13" name="text_608"/>
           <p:cNvSpPr txBox="1"/>
           <p:nvPr/>
         </p:nvSpPr>
@@ -24413,7 +24518,7 @@
       </p:sp>
       <p:sp>
         <p:nvSpPr>
-          <p:cNvPr id="14" name="text_607"/>
+          <p:cNvPr id="14" name="text_609"/>
           <p:cNvSpPr txBox="1"/>
           <p:nvPr/>
         </p:nvSpPr>
@@ -24449,7 +24554,7 @@
       </p:sp>
       <p:sp>
         <p:nvSpPr>
-          <p:cNvPr id="15" name="line_608"/>
+          <p:cNvPr id="15" name="line_610"/>
           <p:cNvSpPr/>
           <p:nvPr/>
         </p:nvSpPr>
@@ -24472,7 +24577,7 @@
       </p:sp>
       <p:sp>
         <p:nvSpPr>
-          <p:cNvPr id="16" name="text_609"/>
+          <p:cNvPr id="16" name="text_611"/>
           <p:cNvSpPr txBox="1"/>
           <p:nvPr/>
         </p:nvSpPr>
@@ -24519,7 +24624,7 @@
       </p:sp>
       <p:sp>
         <p:nvSpPr>
-          <p:cNvPr id="17" name="chip_610"/>
+          <p:cNvPr id="17" name="chip_612"/>
           <p:cNvSpPr txBox="1"/>
           <p:nvPr/>
         </p:nvSpPr>
@@ -24559,7 +24664,7 @@
       </p:sp>
       <p:sp>
         <p:nvSpPr>
-          <p:cNvPr id="18" name="card_611"/>
+          <p:cNvPr id="18" name="card_613"/>
           <p:cNvSpPr/>
           <p:nvPr/>
         </p:nvSpPr>
@@ -24593,7 +24698,7 @@
       </p:sp>
       <p:sp>
         <p:nvSpPr>
-          <p:cNvPr id="19" name="text_612"/>
+          <p:cNvPr id="19" name="text_614"/>
           <p:cNvSpPr txBox="1"/>
           <p:nvPr/>
         </p:nvSpPr>
@@ -24629,7 +24734,7 @@
       </p:sp>
       <p:sp>
         <p:nvSpPr>
-          <p:cNvPr id="20" name="text_613"/>
+          <p:cNvPr id="20" name="text_615"/>
           <p:cNvSpPr txBox="1"/>
           <p:nvPr/>
         </p:nvSpPr>
@@ -24665,7 +24770,7 @@
       </p:sp>
       <p:sp>
         <p:nvSpPr>
-          <p:cNvPr id="21" name="text_614"/>
+          <p:cNvPr id="21" name="text_616"/>
           <p:cNvSpPr txBox="1"/>
           <p:nvPr/>
         </p:nvSpPr>
@@ -24701,7 +24806,7 @@
       </p:sp>
       <p:sp>
         <p:nvSpPr>
-          <p:cNvPr id="22" name="line_615"/>
+          <p:cNvPr id="22" name="line_617"/>
           <p:cNvSpPr/>
           <p:nvPr/>
         </p:nvSpPr>
@@ -24724,7 +24829,7 @@
       </p:sp>
       <p:sp>
         <p:nvSpPr>
-          <p:cNvPr id="23" name="text_616"/>
+          <p:cNvPr id="23" name="text_618"/>
           <p:cNvSpPr txBox="1"/>
           <p:nvPr/>
         </p:nvSpPr>
@@ -24771,7 +24876,7 @@
       </p:sp>
       <p:sp>
         <p:nvSpPr>
-          <p:cNvPr id="24" name="chip_617"/>
+          <p:cNvPr id="24" name="chip_619"/>
           <p:cNvSpPr txBox="1"/>
           <p:nvPr/>
         </p:nvSpPr>
@@ -24811,7 +24916,7 @@
       </p:sp>
       <p:sp>
         <p:nvSpPr>
-          <p:cNvPr id="25" name="card_618"/>
+          <p:cNvPr id="25" name="card_620"/>
           <p:cNvSpPr/>
           <p:nvPr/>
         </p:nvSpPr>
@@ -24845,7 +24950,7 @@
       </p:sp>
       <p:sp>
         <p:nvSpPr>
-          <p:cNvPr id="26" name="text_619"/>
+          <p:cNvPr id="26" name="text_621"/>
           <p:cNvSpPr txBox="1"/>
           <p:nvPr/>
         </p:nvSpPr>
@@ -24881,7 +24986,7 @@
       </p:sp>
       <p:sp>
         <p:nvSpPr>
-          <p:cNvPr id="27" name="text_620"/>
+          <p:cNvPr id="27" name="text_622"/>
           <p:cNvSpPr txBox="1"/>
           <p:nvPr/>
         </p:nvSpPr>
@@ -24917,7 +25022,7 @@
       </p:sp>
       <p:sp>
         <p:nvSpPr>
-          <p:cNvPr id="28" name="text_621"/>
+          <p:cNvPr id="28" name="text_623"/>
           <p:cNvSpPr txBox="1"/>
           <p:nvPr/>
         </p:nvSpPr>
@@ -24953,7 +25058,7 @@
       </p:sp>
       <p:sp>
         <p:nvSpPr>
-          <p:cNvPr id="29" name="line_622"/>
+          <p:cNvPr id="29" name="line_624"/>
           <p:cNvSpPr/>
           <p:nvPr/>
         </p:nvSpPr>
@@ -24976,7 +25081,7 @@
       </p:sp>
       <p:sp>
         <p:nvSpPr>
-          <p:cNvPr id="30" name="text_623"/>
+          <p:cNvPr id="30" name="text_625"/>
           <p:cNvSpPr txBox="1"/>
           <p:nvPr/>
         </p:nvSpPr>
@@ -25023,7 +25128,7 @@
       </p:sp>
       <p:sp>
         <p:nvSpPr>
-          <p:cNvPr id="31" name="chip_624"/>
+          <p:cNvPr id="31" name="chip_626"/>
           <p:cNvSpPr txBox="1"/>
           <p:nvPr/>
         </p:nvSpPr>
@@ -25063,7 +25168,7 @@
       </p:sp>
       <p:sp>
         <p:nvSpPr>
-          <p:cNvPr id="32" name="card_625"/>
+          <p:cNvPr id="32" name="card_627"/>
           <p:cNvSpPr/>
           <p:nvPr/>
         </p:nvSpPr>
@@ -25097,7 +25202,7 @@
       </p:sp>
       <p:sp>
         <p:nvSpPr>
-          <p:cNvPr id="33" name="text_626"/>
+          <p:cNvPr id="33" name="text_628"/>
           <p:cNvSpPr txBox="1"/>
           <p:nvPr/>
         </p:nvSpPr>
@@ -25133,7 +25238,7 @@
       </p:sp>
       <p:sp>
         <p:nvSpPr>
-          <p:cNvPr id="34" name="text_627"/>
+          <p:cNvPr id="34" name="text_629"/>
           <p:cNvSpPr txBox="1"/>
           <p:nvPr/>
         </p:nvSpPr>
@@ -25169,7 +25274,7 @@
       </p:sp>
       <p:sp>
         <p:nvSpPr>
-          <p:cNvPr id="35" name="text_628"/>
+          <p:cNvPr id="35" name="text_630"/>
           <p:cNvSpPr txBox="1"/>
           <p:nvPr/>
         </p:nvSpPr>
@@ -25205,7 +25310,7 @@
       </p:sp>
       <p:sp>
         <p:nvSpPr>
-          <p:cNvPr id="36" name="line_629"/>
+          <p:cNvPr id="36" name="line_631"/>
           <p:cNvSpPr/>
           <p:nvPr/>
         </p:nvSpPr>
@@ -25228,7 +25333,7 @@
       </p:sp>
       <p:sp>
         <p:nvSpPr>
-          <p:cNvPr id="37" name="text_630"/>
+          <p:cNvPr id="37" name="text_632"/>
           <p:cNvSpPr txBox="1"/>
           <p:nvPr/>
         </p:nvSpPr>
@@ -25275,7 +25380,7 @@
       </p:sp>
       <p:sp>
         <p:nvSpPr>
-          <p:cNvPr id="38" name="chip_631"/>
+          <p:cNvPr id="38" name="chip_633"/>
           <p:cNvSpPr txBox="1"/>
           <p:nvPr/>
         </p:nvSpPr>
@@ -25315,7 +25420,7 @@
       </p:sp>
       <p:sp>
         <p:nvSpPr>
-          <p:cNvPr id="39" name="card_632"/>
+          <p:cNvPr id="39" name="card_634"/>
           <p:cNvSpPr/>
           <p:nvPr/>
         </p:nvSpPr>
@@ -25349,7 +25454,7 @@
       </p:sp>
       <p:sp>
         <p:nvSpPr>
-          <p:cNvPr id="40" name="text_633"/>
+          <p:cNvPr id="40" name="text_635"/>
           <p:cNvSpPr txBox="1"/>
           <p:nvPr/>
         </p:nvSpPr>
@@ -25385,7 +25490,7 @@
       </p:sp>
       <p:sp>
         <p:nvSpPr>
-          <p:cNvPr id="41" name="text_634"/>
+          <p:cNvPr id="41" name="text_636"/>
           <p:cNvSpPr txBox="1"/>
           <p:nvPr/>
         </p:nvSpPr>
@@ -25421,7 +25526,7 @@
       </p:sp>
       <p:sp>
         <p:nvSpPr>
-          <p:cNvPr id="42" name="text_635"/>
+          <p:cNvPr id="42" name="text_637"/>
           <p:cNvSpPr txBox="1"/>
           <p:nvPr/>
         </p:nvSpPr>
@@ -25457,7 +25562,7 @@
       </p:sp>
       <p:sp>
         <p:nvSpPr>
-          <p:cNvPr id="43" name="line_636"/>
+          <p:cNvPr id="43" name="line_638"/>
           <p:cNvSpPr/>
           <p:nvPr/>
         </p:nvSpPr>
@@ -25480,7 +25585,7 @@
       </p:sp>
       <p:sp>
         <p:nvSpPr>
-          <p:cNvPr id="44" name="text_637"/>
+          <p:cNvPr id="44" name="text_639"/>
           <p:cNvSpPr txBox="1"/>
           <p:nvPr/>
         </p:nvSpPr>
@@ -25527,7 +25632,7 @@
       </p:sp>
       <p:sp>
         <p:nvSpPr>
-          <p:cNvPr id="45" name="chip_638"/>
+          <p:cNvPr id="45" name="chip_640"/>
           <p:cNvSpPr txBox="1"/>
           <p:nvPr/>
         </p:nvSpPr>
@@ -25675,7 +25780,7 @@
       </p:sp>
       <p:sp>
         <p:nvSpPr>
-          <p:cNvPr id="4" name="card_639"/>
+          <p:cNvPr id="4" name="card_641"/>
           <p:cNvSpPr/>
           <p:nvPr/>
         </p:nvSpPr>
@@ -25704,7 +25809,7 @@
       </p:sp>
       <p:sp>
         <p:nvSpPr>
-          <p:cNvPr id="5" name="text_640"/>
+          <p:cNvPr id="5" name="text_642"/>
           <p:cNvSpPr txBox="1"/>
           <p:nvPr/>
         </p:nvSpPr>
@@ -25897,7 +26002,7 @@
       </p:sp>
       <p:sp>
         <p:nvSpPr>
-          <p:cNvPr id="6" name="card_641"/>
+          <p:cNvPr id="6" name="card_643"/>
           <p:cNvSpPr/>
           <p:nvPr/>
         </p:nvSpPr>
@@ -25919,7 +26024,7 @@
       </p:sp>
       <p:sp>
         <p:nvSpPr>
-          <p:cNvPr id="7" name="chip_642"/>
+          <p:cNvPr id="7" name="chip_644"/>
           <p:cNvSpPr txBox="1"/>
           <p:nvPr/>
         </p:nvSpPr>
@@ -25959,7 +26064,7 @@
       </p:sp>
       <p:sp>
         <p:nvSpPr>
-          <p:cNvPr id="8" name="text_643"/>
+          <p:cNvPr id="8" name="text_645"/>
           <p:cNvSpPr txBox="1"/>
           <p:nvPr/>
         </p:nvSpPr>
@@ -25998,7 +26103,7 @@
       </p:sp>
       <p:sp>
         <p:nvSpPr>
-          <p:cNvPr id="9" name="text_644"/>
+          <p:cNvPr id="9" name="text_646"/>
           <p:cNvSpPr txBox="1"/>
           <p:nvPr/>
         </p:nvSpPr>
@@ -26048,7 +26153,7 @@
       </p:sp>
       <p:sp>
         <p:nvSpPr>
-          <p:cNvPr id="10" name="line_645"/>
+          <p:cNvPr id="10" name="line_647"/>
           <p:cNvSpPr/>
           <p:nvPr/>
         </p:nvSpPr>
@@ -26072,7 +26177,7 @@
       </p:sp>
       <p:sp>
         <p:nvSpPr>
-          <p:cNvPr id="11" name="card_646"/>
+          <p:cNvPr id="11" name="card_648"/>
           <p:cNvSpPr/>
           <p:nvPr/>
         </p:nvSpPr>
@@ -26094,7 +26199,7 @@
       </p:sp>
       <p:sp>
         <p:nvSpPr>
-          <p:cNvPr id="12" name="chip_647"/>
+          <p:cNvPr id="12" name="chip_649"/>
           <p:cNvSpPr txBox="1"/>
           <p:nvPr/>
         </p:nvSpPr>
@@ -26134,7 +26239,7 @@
       </p:sp>
       <p:sp>
         <p:nvSpPr>
-          <p:cNvPr id="13" name="text_648"/>
+          <p:cNvPr id="13" name="text_650"/>
           <p:cNvSpPr txBox="1"/>
           <p:nvPr/>
         </p:nvSpPr>
@@ -26173,7 +26278,7 @@
       </p:sp>
       <p:sp>
         <p:nvSpPr>
-          <p:cNvPr id="14" name="text_649"/>
+          <p:cNvPr id="14" name="text_651"/>
           <p:cNvSpPr txBox="1"/>
           <p:nvPr/>
         </p:nvSpPr>
@@ -26223,7 +26328,7 @@
       </p:sp>
       <p:sp>
         <p:nvSpPr>
-          <p:cNvPr id="15" name="line_650"/>
+          <p:cNvPr id="15" name="line_652"/>
           <p:cNvSpPr/>
           <p:nvPr/>
         </p:nvSpPr>
@@ -26247,7 +26352,7 @@
       </p:sp>
       <p:sp>
         <p:nvSpPr>
-          <p:cNvPr id="16" name="card_651"/>
+          <p:cNvPr id="16" name="card_653"/>
           <p:cNvSpPr/>
           <p:nvPr/>
         </p:nvSpPr>
@@ -26269,7 +26374,7 @@
       </p:sp>
       <p:sp>
         <p:nvSpPr>
-          <p:cNvPr id="17" name="chip_652"/>
+          <p:cNvPr id="17" name="chip_654"/>
           <p:cNvSpPr txBox="1"/>
           <p:nvPr/>
         </p:nvSpPr>
@@ -26309,7 +26414,7 @@
       </p:sp>
       <p:sp>
         <p:nvSpPr>
-          <p:cNvPr id="18" name="text_653"/>
+          <p:cNvPr id="18" name="text_655"/>
           <p:cNvSpPr txBox="1"/>
           <p:nvPr/>
         </p:nvSpPr>
@@ -26348,7 +26453,7 @@
       </p:sp>
       <p:sp>
         <p:nvSpPr>
-          <p:cNvPr id="19" name="text_654"/>
+          <p:cNvPr id="19" name="text_656"/>
           <p:cNvSpPr txBox="1"/>
           <p:nvPr/>
         </p:nvSpPr>
@@ -26412,7 +26517,7 @@
       </p:sp>
       <p:sp>
         <p:nvSpPr>
-          <p:cNvPr id="20" name="line_655"/>
+          <p:cNvPr id="20" name="line_657"/>
           <p:cNvSpPr/>
           <p:nvPr/>
         </p:nvSpPr>
@@ -26436,7 +26541,7 @@
       </p:sp>
       <p:sp>
         <p:nvSpPr>
-          <p:cNvPr id="21" name="card_656"/>
+          <p:cNvPr id="21" name="card_658"/>
           <p:cNvSpPr/>
           <p:nvPr/>
         </p:nvSpPr>
@@ -26458,7 +26563,7 @@
       </p:sp>
       <p:sp>
         <p:nvSpPr>
-          <p:cNvPr id="22" name="chip_657"/>
+          <p:cNvPr id="22" name="chip_659"/>
           <p:cNvSpPr txBox="1"/>
           <p:nvPr/>
         </p:nvSpPr>
@@ -26498,7 +26603,7 @@
       </p:sp>
       <p:sp>
         <p:nvSpPr>
-          <p:cNvPr id="23" name="text_658"/>
+          <p:cNvPr id="23" name="text_660"/>
           <p:cNvSpPr txBox="1"/>
           <p:nvPr/>
         </p:nvSpPr>
@@ -26537,7 +26642,7 @@
       </p:sp>
       <p:sp>
         <p:nvSpPr>
-          <p:cNvPr id="24" name="text_659"/>
+          <p:cNvPr id="24" name="text_661"/>
           <p:cNvSpPr txBox="1"/>
           <p:nvPr/>
         </p:nvSpPr>
@@ -26587,7 +26692,7 @@
       </p:sp>
       <p:sp>
         <p:nvSpPr>
-          <p:cNvPr id="25" name="text_660"/>
+          <p:cNvPr id="25" name="text_662"/>
           <p:cNvSpPr txBox="1"/>
           <p:nvPr/>
         </p:nvSpPr>
@@ -26731,7 +26836,7 @@
       </p:sp>
       <p:sp>
         <p:nvSpPr>
-          <p:cNvPr id="4" name="card_661"/>
+          <p:cNvPr id="4" name="card_663"/>
           <p:cNvSpPr/>
           <p:nvPr/>
         </p:nvSpPr>
@@ -26753,7 +26858,7 @@
       </p:sp>
       <p:sp>
         <p:nvSpPr>
-          <p:cNvPr id="5" name="text_662"/>
+          <p:cNvPr id="5" name="text_664"/>
           <p:cNvSpPr txBox="1"/>
           <p:nvPr/>
         </p:nvSpPr>
@@ -26789,7 +26894,7 @@
       </p:sp>
       <p:sp>
         <p:nvSpPr>
-          <p:cNvPr id="6" name="text_663"/>
+          <p:cNvPr id="6" name="text_665"/>
           <p:cNvSpPr txBox="1"/>
           <p:nvPr/>
         </p:nvSpPr>
@@ -26825,7 +26930,7 @@
       </p:sp>
       <p:sp>
         <p:nvSpPr>
-          <p:cNvPr id="7" name="text_664"/>
+          <p:cNvPr id="7" name="text_666"/>
           <p:cNvSpPr txBox="1"/>
           <p:nvPr/>
         </p:nvSpPr>
@@ -26861,7 +26966,7 @@
       </p:sp>
       <p:sp>
         <p:nvSpPr>
-          <p:cNvPr id="8" name="text_665"/>
+          <p:cNvPr id="8" name="text_667"/>
           <p:cNvSpPr txBox="1"/>
           <p:nvPr/>
         </p:nvSpPr>
@@ -26897,7 +27002,7 @@
       </p:sp>
       <p:sp>
         <p:nvSpPr>
-          <p:cNvPr id="9" name="card_666"/>
+          <p:cNvPr id="9" name="card_668"/>
           <p:cNvSpPr/>
           <p:nvPr/>
         </p:nvSpPr>
@@ -26919,7 +27024,7 @@
       </p:sp>
       <p:sp>
         <p:nvSpPr>
-          <p:cNvPr id="10" name="text_667"/>
+          <p:cNvPr id="10" name="text_669"/>
           <p:cNvSpPr txBox="1"/>
           <p:nvPr/>
         </p:nvSpPr>
@@ -26955,7 +27060,7 @@
       </p:sp>
       <p:sp>
         <p:nvSpPr>
-          <p:cNvPr id="11" name="text_668"/>
+          <p:cNvPr id="11" name="text_670"/>
           <p:cNvSpPr txBox="1"/>
           <p:nvPr/>
         </p:nvSpPr>
@@ -26991,7 +27096,7 @@
       </p:sp>
       <p:sp>
         <p:nvSpPr>
-          <p:cNvPr id="12" name="text_669"/>
+          <p:cNvPr id="12" name="text_671"/>
           <p:cNvSpPr txBox="1"/>
           <p:nvPr/>
         </p:nvSpPr>
@@ -27027,7 +27132,7 @@
       </p:sp>
       <p:sp>
         <p:nvSpPr>
-          <p:cNvPr id="13" name="text_670"/>
+          <p:cNvPr id="13" name="text_672"/>
           <p:cNvSpPr txBox="1"/>
           <p:nvPr/>
         </p:nvSpPr>
@@ -27063,7 +27168,7 @@
       </p:sp>
       <p:sp>
         <p:nvSpPr>
-          <p:cNvPr id="14" name="card_671"/>
+          <p:cNvPr id="14" name="card_673"/>
           <p:cNvSpPr/>
           <p:nvPr/>
         </p:nvSpPr>
@@ -27085,7 +27190,7 @@
       </p:sp>
       <p:sp>
         <p:nvSpPr>
-          <p:cNvPr id="15" name="text_672"/>
+          <p:cNvPr id="15" name="text_674"/>
           <p:cNvSpPr txBox="1"/>
           <p:nvPr/>
         </p:nvSpPr>
@@ -27121,7 +27226,7 @@
       </p:sp>
       <p:sp>
         <p:nvSpPr>
-          <p:cNvPr id="16" name="text_673"/>
+          <p:cNvPr id="16" name="text_675"/>
           <p:cNvSpPr txBox="1"/>
           <p:nvPr/>
         </p:nvSpPr>
@@ -27157,7 +27262,7 @@
       </p:sp>
       <p:sp>
         <p:nvSpPr>
-          <p:cNvPr id="17" name="text_674"/>
+          <p:cNvPr id="17" name="text_676"/>
           <p:cNvSpPr txBox="1"/>
           <p:nvPr/>
         </p:nvSpPr>
@@ -27193,7 +27298,7 @@
       </p:sp>
       <p:sp>
         <p:nvSpPr>
-          <p:cNvPr id="18" name="text_675"/>
+          <p:cNvPr id="18" name="text_677"/>
           <p:cNvSpPr txBox="1"/>
           <p:nvPr/>
         </p:nvSpPr>
@@ -27229,7 +27334,7 @@
       </p:sp>
       <p:sp>
         <p:nvSpPr>
-          <p:cNvPr id="19" name="card_676"/>
+          <p:cNvPr id="19" name="card_678"/>
           <p:cNvSpPr/>
           <p:nvPr/>
         </p:nvSpPr>
@@ -27251,7 +27356,7 @@
       </p:sp>
       <p:sp>
         <p:nvSpPr>
-          <p:cNvPr id="20" name="text_677"/>
+          <p:cNvPr id="20" name="text_679"/>
           <p:cNvSpPr txBox="1"/>
           <p:nvPr/>
         </p:nvSpPr>
@@ -27287,7 +27392,7 @@
       </p:sp>
       <p:sp>
         <p:nvSpPr>
-          <p:cNvPr id="21" name="text_678"/>
+          <p:cNvPr id="21" name="text_680"/>
           <p:cNvSpPr txBox="1"/>
           <p:nvPr/>
         </p:nvSpPr>
@@ -27323,7 +27428,7 @@
       </p:sp>
       <p:sp>
         <p:nvSpPr>
-          <p:cNvPr id="22" name="text_679"/>
+          <p:cNvPr id="22" name="text_681"/>
           <p:cNvSpPr txBox="1"/>
           <p:nvPr/>
         </p:nvSpPr>
@@ -27359,7 +27464,7 @@
       </p:sp>
       <p:sp>
         <p:nvSpPr>
-          <p:cNvPr id="23" name="text_680"/>
+          <p:cNvPr id="23" name="text_682"/>
           <p:cNvSpPr txBox="1"/>
           <p:nvPr/>
         </p:nvSpPr>
@@ -27395,7 +27500,7 @@
       </p:sp>
       <p:sp>
         <p:nvSpPr>
-          <p:cNvPr id="24" name="card_681"/>
+          <p:cNvPr id="24" name="card_683"/>
           <p:cNvSpPr/>
           <p:nvPr/>
         </p:nvSpPr>
@@ -27424,7 +27529,7 @@
       </p:sp>
       <p:sp>
         <p:nvSpPr>
-          <p:cNvPr id="25" name="text_682"/>
+          <p:cNvPr id="25" name="text_684"/>
           <p:cNvSpPr txBox="1"/>
           <p:nvPr/>
         </p:nvSpPr>
@@ -27669,7 +27774,7 @@
       </p:sp>
       <p:sp>
         <p:nvSpPr>
-          <p:cNvPr id="4" name="card_683"/>
+          <p:cNvPr id="4" name="card_685"/>
           <p:cNvSpPr/>
           <p:nvPr/>
         </p:nvSpPr>
@@ -27691,7 +27796,7 @@
       </p:sp>
       <p:pic>
         <p:nvPicPr>
-          <p:cNvPr id="5" name="icon_684" descr="preencoded.png">    </p:cNvPr>
+          <p:cNvPr id="5" name="icon_686" descr="preencoded.png">    </p:cNvPr>
           <p:cNvPicPr>
             <a:picLocks noChangeAspect="1"/>
           </p:cNvPicPr>
@@ -27715,7 +27820,7 @@
       </p:pic>
       <p:sp>
         <p:nvSpPr>
-          <p:cNvPr id="6" name="text_685"/>
+          <p:cNvPr id="6" name="text_687"/>
           <p:cNvSpPr txBox="1"/>
           <p:nvPr/>
         </p:nvSpPr>
@@ -27751,7 +27856,7 @@
       </p:sp>
       <p:sp>
         <p:nvSpPr>
-          <p:cNvPr id="7" name="text_686"/>
+          <p:cNvPr id="7" name="text_688"/>
           <p:cNvSpPr txBox="1"/>
           <p:nvPr/>
         </p:nvSpPr>
@@ -27787,7 +27892,7 @@
       </p:sp>
       <p:sp>
         <p:nvSpPr>
-          <p:cNvPr id="8" name="line_687"/>
+          <p:cNvPr id="8" name="line_689"/>
           <p:cNvSpPr/>
           <p:nvPr/>
         </p:nvSpPr>
@@ -27811,7 +27916,7 @@
       </p:sp>
       <p:sp>
         <p:nvSpPr>
-          <p:cNvPr id="9" name="card_688"/>
+          <p:cNvPr id="9" name="card_690"/>
           <p:cNvSpPr/>
           <p:nvPr/>
         </p:nvSpPr>
@@ -27840,7 +27945,7 @@
       </p:sp>
       <p:pic>
         <p:nvPicPr>
-          <p:cNvPr id="10" name="icon_689" descr="preencoded.png">    </p:cNvPr>
+          <p:cNvPr id="10" name="icon_691" descr="preencoded.png">    </p:cNvPr>
           <p:cNvPicPr>
             <a:picLocks noChangeAspect="1"/>
           </p:cNvPicPr>
@@ -27864,7 +27969,7 @@
       </p:pic>
       <p:sp>
         <p:nvSpPr>
-          <p:cNvPr id="11" name="text_690"/>
+          <p:cNvPr id="11" name="text_692"/>
           <p:cNvSpPr txBox="1"/>
           <p:nvPr/>
         </p:nvSpPr>
@@ -27900,7 +28005,7 @@
       </p:sp>
       <p:sp>
         <p:nvSpPr>
-          <p:cNvPr id="12" name="text_691"/>
+          <p:cNvPr id="12" name="text_693"/>
           <p:cNvSpPr txBox="1"/>
           <p:nvPr/>
         </p:nvSpPr>
@@ -27936,7 +28041,7 @@
       </p:sp>
       <p:sp>
         <p:nvSpPr>
-          <p:cNvPr id="13" name="text_692"/>
+          <p:cNvPr id="13" name="text_694"/>
           <p:cNvSpPr txBox="1"/>
           <p:nvPr/>
         </p:nvSpPr>
@@ -27972,7 +28077,7 @@
       </p:sp>
       <p:sp>
         <p:nvSpPr>
-          <p:cNvPr id="14" name="card_693"/>
+          <p:cNvPr id="14" name="card_695"/>
           <p:cNvSpPr/>
           <p:nvPr/>
         </p:nvSpPr>
@@ -27994,7 +28099,7 @@
       </p:sp>
       <p:pic>
         <p:nvPicPr>
-          <p:cNvPr id="15" name="icon_694" descr="preencoded.png">    </p:cNvPr>
+          <p:cNvPr id="15" name="icon_696" descr="preencoded.png">    </p:cNvPr>
           <p:cNvPicPr>
             <a:picLocks noChangeAspect="1"/>
           </p:cNvPicPr>
@@ -28018,7 +28123,7 @@
       </p:pic>
       <p:sp>
         <p:nvSpPr>
-          <p:cNvPr id="16" name="text_695"/>
+          <p:cNvPr id="16" name="text_697"/>
           <p:cNvSpPr txBox="1"/>
           <p:nvPr/>
         </p:nvSpPr>
@@ -28054,7 +28159,7 @@
       </p:sp>
       <p:sp>
         <p:nvSpPr>
-          <p:cNvPr id="17" name="text_696"/>
+          <p:cNvPr id="17" name="text_698"/>
           <p:cNvSpPr txBox="1"/>
           <p:nvPr/>
         </p:nvSpPr>
@@ -28090,7 +28195,7 @@
       </p:sp>
       <p:sp>
         <p:nvSpPr>
-          <p:cNvPr id="18" name="line_697"/>
+          <p:cNvPr id="18" name="line_699"/>
           <p:cNvSpPr/>
           <p:nvPr/>
         </p:nvSpPr>
@@ -28114,7 +28219,7 @@
       </p:sp>
       <p:sp>
         <p:nvSpPr>
-          <p:cNvPr id="19" name="card_698"/>
+          <p:cNvPr id="19" name="card_700"/>
           <p:cNvSpPr/>
           <p:nvPr/>
         </p:nvSpPr>
@@ -28143,7 +28248,7 @@
       </p:sp>
       <p:pic>
         <p:nvPicPr>
-          <p:cNvPr id="20" name="icon_699" descr="preencoded.png">    </p:cNvPr>
+          <p:cNvPr id="20" name="icon_701" descr="preencoded.png">    </p:cNvPr>
           <p:cNvPicPr>
             <a:picLocks noChangeAspect="1"/>
           </p:cNvPicPr>
@@ -28167,7 +28272,7 @@
       </p:pic>
       <p:sp>
         <p:nvSpPr>
-          <p:cNvPr id="21" name="text_700"/>
+          <p:cNvPr id="21" name="text_702"/>
           <p:cNvSpPr txBox="1"/>
           <p:nvPr/>
         </p:nvSpPr>
@@ -28203,7 +28308,7 @@
       </p:sp>
       <p:sp>
         <p:nvSpPr>
-          <p:cNvPr id="22" name="text_701"/>
+          <p:cNvPr id="22" name="text_703"/>
           <p:cNvSpPr txBox="1"/>
           <p:nvPr/>
         </p:nvSpPr>
@@ -28239,7 +28344,7 @@
       </p:sp>
       <p:sp>
         <p:nvSpPr>
-          <p:cNvPr id="23" name="text_702"/>
+          <p:cNvPr id="23" name="text_704"/>
           <p:cNvSpPr txBox="1"/>
           <p:nvPr/>
         </p:nvSpPr>
@@ -28275,7 +28380,7 @@
       </p:sp>
       <p:sp>
         <p:nvSpPr>
-          <p:cNvPr id="24" name="card_703"/>
+          <p:cNvPr id="24" name="card_705"/>
           <p:cNvSpPr/>
           <p:nvPr/>
         </p:nvSpPr>
@@ -28297,7 +28402,7 @@
       </p:sp>
       <p:pic>
         <p:nvPicPr>
-          <p:cNvPr id="25" name="icon_704" descr="preencoded.png">    </p:cNvPr>
+          <p:cNvPr id="25" name="icon_706" descr="preencoded.png">    </p:cNvPr>
           <p:cNvPicPr>
             <a:picLocks noChangeAspect="1"/>
           </p:cNvPicPr>
@@ -28321,7 +28426,7 @@
       </p:pic>
       <p:sp>
         <p:nvSpPr>
-          <p:cNvPr id="26" name="text_705"/>
+          <p:cNvPr id="26" name="text_707"/>
           <p:cNvSpPr txBox="1"/>
           <p:nvPr/>
         </p:nvSpPr>
@@ -28357,7 +28462,7 @@
       </p:sp>
       <p:sp>
         <p:nvSpPr>
-          <p:cNvPr id="27" name="text_706"/>
+          <p:cNvPr id="27" name="text_708"/>
           <p:cNvSpPr txBox="1"/>
           <p:nvPr/>
         </p:nvSpPr>
@@ -28393,7 +28498,7 @@
       </p:sp>
       <p:sp>
         <p:nvSpPr>
-          <p:cNvPr id="28" name="line_707"/>
+          <p:cNvPr id="28" name="line_709"/>
           <p:cNvSpPr/>
           <p:nvPr/>
         </p:nvSpPr>
@@ -28417,7 +28522,7 @@
       </p:sp>
       <p:sp>
         <p:nvSpPr>
-          <p:cNvPr id="29" name="card_708"/>
+          <p:cNvPr id="29" name="card_710"/>
           <p:cNvSpPr/>
           <p:nvPr/>
         </p:nvSpPr>
@@ -28446,7 +28551,7 @@
       </p:sp>
       <p:pic>
         <p:nvPicPr>
-          <p:cNvPr id="30" name="icon_709" descr="preencoded.png">    </p:cNvPr>
+          <p:cNvPr id="30" name="icon_711" descr="preencoded.png">    </p:cNvPr>
           <p:cNvPicPr>
             <a:picLocks noChangeAspect="1"/>
           </p:cNvPicPr>
@@ -28470,7 +28575,7 @@
       </p:pic>
       <p:sp>
         <p:nvSpPr>
-          <p:cNvPr id="31" name="text_710"/>
+          <p:cNvPr id="31" name="text_712"/>
           <p:cNvSpPr txBox="1"/>
           <p:nvPr/>
         </p:nvSpPr>
@@ -28506,7 +28611,7 @@
       </p:sp>
       <p:sp>
         <p:nvSpPr>
-          <p:cNvPr id="32" name="text_711"/>
+          <p:cNvPr id="32" name="text_713"/>
           <p:cNvSpPr txBox="1"/>
           <p:nvPr/>
         </p:nvSpPr>
@@ -28542,7 +28647,7 @@
       </p:sp>
       <p:sp>
         <p:nvSpPr>
-          <p:cNvPr id="33" name="text_712"/>
+          <p:cNvPr id="33" name="text_714"/>
           <p:cNvSpPr txBox="1"/>
           <p:nvPr/>
         </p:nvSpPr>
@@ -28678,7 +28783,7 @@
                   <a:schemeClr val="tx2"/>
                 </a:solidFill>
               </a:rPr>
-              <a:t>결과를 바꾸는 습관 일곱 가지</a:t>
+              <a:t>프롬프트 작성 요령 일곱 가지</a:t>
             </a:r>
             <a:endParaRPr lang="en-US" sz="3200" dirty="0"/>
           </a:p>
@@ -28686,7 +28791,7 @@
       </p:sp>
       <p:sp>
         <p:nvSpPr>
-          <p:cNvPr id="4" name="badge_713"/>
+          <p:cNvPr id="4" name="badge_715"/>
           <p:cNvSpPr txBox="1"/>
           <p:nvPr/>
         </p:nvSpPr>
@@ -28724,7 +28829,7 @@
       </p:sp>
       <p:sp>
         <p:nvSpPr>
-          <p:cNvPr id="5" name="text_714"/>
+          <p:cNvPr id="5" name="text_716"/>
           <p:cNvSpPr txBox="1"/>
           <p:nvPr/>
         </p:nvSpPr>
@@ -28760,7 +28865,7 @@
       </p:sp>
       <p:sp>
         <p:nvSpPr>
-          <p:cNvPr id="6" name="text_715"/>
+          <p:cNvPr id="6" name="text_717"/>
           <p:cNvSpPr txBox="1"/>
           <p:nvPr/>
         </p:nvSpPr>
@@ -28796,7 +28901,7 @@
       </p:sp>
       <p:sp>
         <p:nvSpPr>
-          <p:cNvPr id="7" name="badge_716"/>
+          <p:cNvPr id="7" name="badge_718"/>
           <p:cNvSpPr txBox="1"/>
           <p:nvPr/>
         </p:nvSpPr>
@@ -28834,7 +28939,7 @@
       </p:sp>
       <p:sp>
         <p:nvSpPr>
-          <p:cNvPr id="8" name="text_717"/>
+          <p:cNvPr id="8" name="text_719"/>
           <p:cNvSpPr txBox="1"/>
           <p:nvPr/>
         </p:nvSpPr>
@@ -28870,7 +28975,7 @@
       </p:sp>
       <p:sp>
         <p:nvSpPr>
-          <p:cNvPr id="9" name="text_718"/>
+          <p:cNvPr id="9" name="text_720"/>
           <p:cNvSpPr txBox="1"/>
           <p:nvPr/>
         </p:nvSpPr>
@@ -28906,7 +29011,7 @@
       </p:sp>
       <p:sp>
         <p:nvSpPr>
-          <p:cNvPr id="10" name="badge_719"/>
+          <p:cNvPr id="10" name="badge_721"/>
           <p:cNvSpPr txBox="1"/>
           <p:nvPr/>
         </p:nvSpPr>
@@ -28944,7 +29049,7 @@
       </p:sp>
       <p:sp>
         <p:nvSpPr>
-          <p:cNvPr id="11" name="text_720"/>
+          <p:cNvPr id="11" name="text_722"/>
           <p:cNvSpPr txBox="1"/>
           <p:nvPr/>
         </p:nvSpPr>
@@ -28980,7 +29085,7 @@
       </p:sp>
       <p:sp>
         <p:nvSpPr>
-          <p:cNvPr id="12" name="text_721"/>
+          <p:cNvPr id="12" name="text_723"/>
           <p:cNvSpPr txBox="1"/>
           <p:nvPr/>
         </p:nvSpPr>
@@ -29016,7 +29121,7 @@
       </p:sp>
       <p:sp>
         <p:nvSpPr>
-          <p:cNvPr id="13" name="badge_722"/>
+          <p:cNvPr id="13" name="badge_724"/>
           <p:cNvSpPr txBox="1"/>
           <p:nvPr/>
         </p:nvSpPr>
@@ -29054,7 +29159,7 @@
       </p:sp>
       <p:sp>
         <p:nvSpPr>
-          <p:cNvPr id="14" name="text_723"/>
+          <p:cNvPr id="14" name="text_725"/>
           <p:cNvSpPr txBox="1"/>
           <p:nvPr/>
         </p:nvSpPr>
@@ -29090,7 +29195,7 @@
       </p:sp>
       <p:sp>
         <p:nvSpPr>
-          <p:cNvPr id="15" name="text_724"/>
+          <p:cNvPr id="15" name="text_726"/>
           <p:cNvSpPr txBox="1"/>
           <p:nvPr/>
         </p:nvSpPr>
@@ -29126,7 +29231,7 @@
       </p:sp>
       <p:sp>
         <p:nvSpPr>
-          <p:cNvPr id="16" name="badge_725"/>
+          <p:cNvPr id="16" name="badge_727"/>
           <p:cNvSpPr txBox="1"/>
           <p:nvPr/>
         </p:nvSpPr>
@@ -29164,7 +29269,7 @@
       </p:sp>
       <p:sp>
         <p:nvSpPr>
-          <p:cNvPr id="17" name="text_726"/>
+          <p:cNvPr id="17" name="text_728"/>
           <p:cNvSpPr txBox="1"/>
           <p:nvPr/>
         </p:nvSpPr>
@@ -29200,7 +29305,7 @@
       </p:sp>
       <p:sp>
         <p:nvSpPr>
-          <p:cNvPr id="18" name="text_727"/>
+          <p:cNvPr id="18" name="text_729"/>
           <p:cNvSpPr txBox="1"/>
           <p:nvPr/>
         </p:nvSpPr>
@@ -29236,7 +29341,7 @@
       </p:sp>
       <p:sp>
         <p:nvSpPr>
-          <p:cNvPr id="19" name="badge_728"/>
+          <p:cNvPr id="19" name="badge_730"/>
           <p:cNvSpPr txBox="1"/>
           <p:nvPr/>
         </p:nvSpPr>
@@ -29274,7 +29379,7 @@
       </p:sp>
       <p:sp>
         <p:nvSpPr>
-          <p:cNvPr id="20" name="text_729"/>
+          <p:cNvPr id="20" name="text_731"/>
           <p:cNvSpPr txBox="1"/>
           <p:nvPr/>
         </p:nvSpPr>
@@ -29310,7 +29415,7 @@
       </p:sp>
       <p:sp>
         <p:nvSpPr>
-          <p:cNvPr id="21" name="text_730"/>
+          <p:cNvPr id="21" name="text_732"/>
           <p:cNvSpPr txBox="1"/>
           <p:nvPr/>
         </p:nvSpPr>
@@ -29346,7 +29451,7 @@
       </p:sp>
       <p:sp>
         <p:nvSpPr>
-          <p:cNvPr id="22" name="badge_731"/>
+          <p:cNvPr id="22" name="badge_733"/>
           <p:cNvSpPr txBox="1"/>
           <p:nvPr/>
         </p:nvSpPr>
@@ -29384,7 +29489,7 @@
       </p:sp>
       <p:sp>
         <p:nvSpPr>
-          <p:cNvPr id="23" name="text_732"/>
+          <p:cNvPr id="23" name="text_734"/>
           <p:cNvSpPr txBox="1"/>
           <p:nvPr/>
         </p:nvSpPr>
@@ -29420,7 +29525,7 @@
       </p:sp>
       <p:sp>
         <p:nvSpPr>
-          <p:cNvPr id="24" name="text_733"/>
+          <p:cNvPr id="24" name="text_735"/>
           <p:cNvSpPr txBox="1"/>
           <p:nvPr/>
         </p:nvSpPr>
@@ -29456,7 +29561,7 @@
       </p:sp>
       <p:sp>
         <p:nvSpPr>
-          <p:cNvPr id="25" name="card_734"/>
+          <p:cNvPr id="25" name="card_736"/>
           <p:cNvSpPr/>
           <p:nvPr/>
         </p:nvSpPr>
@@ -29480,7 +29585,7 @@
       </p:sp>
       <p:sp>
         <p:nvSpPr>
-          <p:cNvPr id="26" name="text_735"/>
+          <p:cNvPr id="26" name="text_737"/>
           <p:cNvSpPr txBox="1"/>
           <p:nvPr/>
         </p:nvSpPr>
@@ -29522,7 +29627,7 @@
                   <a:schemeClr val="tx1"/>
                 </a:solidFill>
               </a:rPr>
-              <a:t>위 습관을 규칙으로 정리한 템플릿. 대화를 시작할 때 한 번 붙여 넣는다.</a:t>
+              <a:t>위 요령을 규칙으로 정리한 템플릿. 대화를 시작할 때 한 번 붙여 넣는다.</a:t>
             </a:r>
             <a:endParaRPr lang="en-US" sz="1350" dirty="0"/>
           </a:p>
@@ -29706,7 +29811,7 @@
                   <a:schemeClr val="bg2"/>
                 </a:solidFill>
               </a:rPr>
-              <a:t>현재 제공되는 18종과 쓰는 방법</a:t>
+              <a:t>공식 워크플로 18종과, 그에 맞춘 프롬프트 템플릿</a:t>
             </a:r>
             <a:endParaRPr lang="en-US" sz="1800" dirty="0"/>
           </a:p>
@@ -30917,7 +31022,7 @@
                   <a:schemeClr val="tx2"/>
                 </a:solidFill>
               </a:rPr>
-              <a:t>현재 제공되는 템플릿 18종</a:t>
+              <a:t>공식 워크플로 18종과 프롬프트 템플릿</a:t>
             </a:r>
             <a:endParaRPr lang="en-US" sz="3200" dirty="0"/>
           </a:p>
@@ -30925,7 +31030,7 @@
       </p:sp>
       <p:sp>
         <p:nvSpPr>
-          <p:cNvPr id="4" name="text_736"/>
+          <p:cNvPr id="4" name="text_738"/>
           <p:cNvSpPr txBox="1"/>
           <p:nvPr/>
         </p:nvSpPr>
@@ -30953,7 +31058,7 @@
                   <a:schemeClr val="accent6"/>
                 </a:solidFill>
               </a:rPr>
-              <a:t>commander-mcp 스킬팩(1.2.1)의 워크플로 18종에 1:1로 맞춘 사람용 프롬프트 템플릿. 전체 문구는 워크북 5장.</a:t>
+              <a:t>Tricentis 스킬팩(1.2.1)이 제공하는 AI용 워크플로 18종에, 이 과정에서 만든 사람용 프롬프트 템플릿을 1:1로 맞췄다. 전체 문구는 워크북 5장.</a:t>
             </a:r>
             <a:endParaRPr lang="en-US" sz="1400" dirty="0"/>
           </a:p>
@@ -30961,7 +31066,7 @@
       </p:sp>
       <p:sp>
         <p:nvSpPr>
-          <p:cNvPr id="5" name="chip_737"/>
+          <p:cNvPr id="5" name="chip_739"/>
           <p:cNvSpPr txBox="1"/>
           <p:nvPr/>
         </p:nvSpPr>
@@ -31001,7 +31106,7 @@
       </p:sp>
       <p:sp>
         <p:nvSpPr>
-          <p:cNvPr id="6" name="text_738"/>
+          <p:cNvPr id="6" name="text_740"/>
           <p:cNvSpPr txBox="1"/>
           <p:nvPr/>
         </p:nvSpPr>
@@ -31037,7 +31142,7 @@
       </p:sp>
       <p:sp>
         <p:nvSpPr>
-          <p:cNvPr id="7" name="card_739"/>
+          <p:cNvPr id="7" name="card_741"/>
           <p:cNvSpPr/>
           <p:nvPr/>
         </p:nvSpPr>
@@ -31059,7 +31164,7 @@
       </p:sp>
       <p:sp>
         <p:nvSpPr>
-          <p:cNvPr id="8" name="text_740"/>
+          <p:cNvPr id="8" name="text_742"/>
           <p:cNvSpPr txBox="1"/>
           <p:nvPr/>
         </p:nvSpPr>
@@ -31095,7 +31200,7 @@
       </p:sp>
       <p:sp>
         <p:nvSpPr>
-          <p:cNvPr id="9" name="chip_741"/>
+          <p:cNvPr id="9" name="chip_743"/>
           <p:cNvSpPr txBox="1"/>
           <p:nvPr/>
         </p:nvSpPr>
@@ -31135,7 +31240,7 @@
       </p:sp>
       <p:sp>
         <p:nvSpPr>
-          <p:cNvPr id="10" name="text_742"/>
+          <p:cNvPr id="10" name="text_744"/>
           <p:cNvSpPr txBox="1"/>
           <p:nvPr/>
         </p:nvSpPr>
@@ -31182,7 +31287,7 @@
       </p:sp>
       <p:sp>
         <p:nvSpPr>
-          <p:cNvPr id="11" name="text_743"/>
+          <p:cNvPr id="11" name="text_745"/>
           <p:cNvSpPr txBox="1"/>
           <p:nvPr/>
         </p:nvSpPr>
@@ -31229,7 +31334,7 @@
       </p:sp>
       <p:sp>
         <p:nvSpPr>
-          <p:cNvPr id="12" name="card_744"/>
+          <p:cNvPr id="12" name="card_746"/>
           <p:cNvSpPr/>
           <p:nvPr/>
         </p:nvSpPr>
@@ -31251,7 +31356,7 @@
       </p:sp>
       <p:sp>
         <p:nvSpPr>
-          <p:cNvPr id="13" name="text_745"/>
+          <p:cNvPr id="13" name="text_747"/>
           <p:cNvSpPr txBox="1"/>
           <p:nvPr/>
         </p:nvSpPr>
@@ -31287,7 +31392,7 @@
       </p:sp>
       <p:sp>
         <p:nvSpPr>
-          <p:cNvPr id="14" name="chip_746"/>
+          <p:cNvPr id="14" name="chip_748"/>
           <p:cNvSpPr txBox="1"/>
           <p:nvPr/>
         </p:nvSpPr>
@@ -31327,7 +31432,7 @@
       </p:sp>
       <p:sp>
         <p:nvSpPr>
-          <p:cNvPr id="15" name="text_747"/>
+          <p:cNvPr id="15" name="text_749"/>
           <p:cNvSpPr txBox="1"/>
           <p:nvPr/>
         </p:nvSpPr>
@@ -31374,7 +31479,7 @@
       </p:sp>
       <p:sp>
         <p:nvSpPr>
-          <p:cNvPr id="16" name="card_748"/>
+          <p:cNvPr id="16" name="card_750"/>
           <p:cNvSpPr/>
           <p:nvPr/>
         </p:nvSpPr>
@@ -31396,7 +31501,7 @@
       </p:sp>
       <p:sp>
         <p:nvSpPr>
-          <p:cNvPr id="17" name="text_749"/>
+          <p:cNvPr id="17" name="text_751"/>
           <p:cNvSpPr txBox="1"/>
           <p:nvPr/>
         </p:nvSpPr>
@@ -31432,7 +31537,7 @@
       </p:sp>
       <p:sp>
         <p:nvSpPr>
-          <p:cNvPr id="18" name="chip_750"/>
+          <p:cNvPr id="18" name="chip_752"/>
           <p:cNvSpPr txBox="1"/>
           <p:nvPr/>
         </p:nvSpPr>
@@ -31472,7 +31577,7 @@
       </p:sp>
       <p:sp>
         <p:nvSpPr>
-          <p:cNvPr id="19" name="text_751"/>
+          <p:cNvPr id="19" name="text_753"/>
           <p:cNvSpPr txBox="1"/>
           <p:nvPr/>
         </p:nvSpPr>
@@ -31519,7 +31624,7 @@
       </p:sp>
       <p:sp>
         <p:nvSpPr>
-          <p:cNvPr id="20" name="text_752"/>
+          <p:cNvPr id="20" name="text_754"/>
           <p:cNvSpPr txBox="1"/>
           <p:nvPr/>
         </p:nvSpPr>
@@ -31566,7 +31671,7 @@
       </p:sp>
       <p:sp>
         <p:nvSpPr>
-          <p:cNvPr id="21" name="card_753"/>
+          <p:cNvPr id="21" name="card_755"/>
           <p:cNvSpPr/>
           <p:nvPr/>
         </p:nvSpPr>
@@ -31588,7 +31693,7 @@
       </p:sp>
       <p:sp>
         <p:nvSpPr>
-          <p:cNvPr id="22" name="text_754"/>
+          <p:cNvPr id="22" name="text_756"/>
           <p:cNvSpPr txBox="1"/>
           <p:nvPr/>
         </p:nvSpPr>
@@ -31624,7 +31729,7 @@
       </p:sp>
       <p:sp>
         <p:nvSpPr>
-          <p:cNvPr id="23" name="chip_755"/>
+          <p:cNvPr id="23" name="chip_757"/>
           <p:cNvSpPr txBox="1"/>
           <p:nvPr/>
         </p:nvSpPr>
@@ -31664,7 +31769,7 @@
       </p:sp>
       <p:sp>
         <p:nvSpPr>
-          <p:cNvPr id="24" name="text_756"/>
+          <p:cNvPr id="24" name="text_758"/>
           <p:cNvSpPr txBox="1"/>
           <p:nvPr/>
         </p:nvSpPr>
@@ -31711,7 +31816,7 @@
       </p:sp>
       <p:sp>
         <p:nvSpPr>
-          <p:cNvPr id="25" name="text_757"/>
+          <p:cNvPr id="25" name="text_759"/>
           <p:cNvSpPr txBox="1"/>
           <p:nvPr/>
         </p:nvSpPr>
@@ -31758,7 +31863,7 @@
       </p:sp>
       <p:sp>
         <p:nvSpPr>
-          <p:cNvPr id="26" name="text_758"/>
+          <p:cNvPr id="26" name="text_760"/>
           <p:cNvSpPr txBox="1"/>
           <p:nvPr/>
         </p:nvSpPr>
@@ -31805,7 +31910,7 @@
       </p:sp>
       <p:sp>
         <p:nvSpPr>
-          <p:cNvPr id="27" name="text_759"/>
+          <p:cNvPr id="27" name="text_761"/>
           <p:cNvSpPr txBox="1"/>
           <p:nvPr/>
         </p:nvSpPr>
@@ -31852,7 +31957,7 @@
       </p:sp>
       <p:sp>
         <p:nvSpPr>
-          <p:cNvPr id="28" name="card_760"/>
+          <p:cNvPr id="28" name="card_762"/>
           <p:cNvSpPr/>
           <p:nvPr/>
         </p:nvSpPr>
@@ -31874,7 +31979,7 @@
       </p:sp>
       <p:sp>
         <p:nvSpPr>
-          <p:cNvPr id="29" name="text_761"/>
+          <p:cNvPr id="29" name="text_763"/>
           <p:cNvSpPr txBox="1"/>
           <p:nvPr/>
         </p:nvSpPr>
@@ -31910,7 +32015,7 @@
       </p:sp>
       <p:sp>
         <p:nvSpPr>
-          <p:cNvPr id="30" name="chip_762"/>
+          <p:cNvPr id="30" name="chip_764"/>
           <p:cNvSpPr txBox="1"/>
           <p:nvPr/>
         </p:nvSpPr>
@@ -31950,7 +32055,7 @@
       </p:sp>
       <p:sp>
         <p:nvSpPr>
-          <p:cNvPr id="31" name="text_763"/>
+          <p:cNvPr id="31" name="text_765"/>
           <p:cNvSpPr txBox="1"/>
           <p:nvPr/>
         </p:nvSpPr>
@@ -31997,7 +32102,7 @@
       </p:sp>
       <p:sp>
         <p:nvSpPr>
-          <p:cNvPr id="32" name="text_764"/>
+          <p:cNvPr id="32" name="text_766"/>
           <p:cNvSpPr txBox="1"/>
           <p:nvPr/>
         </p:nvSpPr>
@@ -32044,7 +32149,7 @@
       </p:sp>
       <p:sp>
         <p:nvSpPr>
-          <p:cNvPr id="33" name="card_765"/>
+          <p:cNvPr id="33" name="card_767"/>
           <p:cNvSpPr/>
           <p:nvPr/>
         </p:nvSpPr>
@@ -32066,7 +32171,7 @@
       </p:sp>
       <p:sp>
         <p:nvSpPr>
-          <p:cNvPr id="34" name="text_766"/>
+          <p:cNvPr id="34" name="text_768"/>
           <p:cNvSpPr txBox="1"/>
           <p:nvPr/>
         </p:nvSpPr>
@@ -32102,7 +32207,7 @@
       </p:sp>
       <p:sp>
         <p:nvSpPr>
-          <p:cNvPr id="35" name="chip_767"/>
+          <p:cNvPr id="35" name="chip_769"/>
           <p:cNvSpPr txBox="1"/>
           <p:nvPr/>
         </p:nvSpPr>
@@ -32142,7 +32247,7 @@
       </p:sp>
       <p:sp>
         <p:nvSpPr>
-          <p:cNvPr id="36" name="text_768"/>
+          <p:cNvPr id="36" name="text_770"/>
           <p:cNvSpPr txBox="1"/>
           <p:nvPr/>
         </p:nvSpPr>
@@ -32189,7 +32294,7 @@
       </p:sp>
       <p:sp>
         <p:nvSpPr>
-          <p:cNvPr id="37" name="text_769"/>
+          <p:cNvPr id="37" name="text_771"/>
           <p:cNvSpPr txBox="1"/>
           <p:nvPr/>
         </p:nvSpPr>
@@ -32236,7 +32341,7 @@
       </p:sp>
       <p:sp>
         <p:nvSpPr>
-          <p:cNvPr id="38" name="text_770"/>
+          <p:cNvPr id="38" name="text_772"/>
           <p:cNvSpPr txBox="1"/>
           <p:nvPr/>
         </p:nvSpPr>
@@ -32283,7 +32388,7 @@
       </p:sp>
       <p:sp>
         <p:nvSpPr>
-          <p:cNvPr id="39" name="text_771"/>
+          <p:cNvPr id="39" name="text_773"/>
           <p:cNvSpPr txBox="1"/>
           <p:nvPr/>
         </p:nvSpPr>
@@ -32330,7 +32435,7 @@
       </p:sp>
       <p:sp>
         <p:nvSpPr>
-          <p:cNvPr id="40" name="text_772"/>
+          <p:cNvPr id="40" name="text_774"/>
           <p:cNvSpPr txBox="1"/>
           <p:nvPr/>
         </p:nvSpPr>
@@ -32377,7 +32482,7 @@
       </p:sp>
       <p:sp>
         <p:nvSpPr>
-          <p:cNvPr id="41" name="text_773"/>
+          <p:cNvPr id="41" name="text_775"/>
           <p:cNvSpPr txBox="1"/>
           <p:nvPr/>
         </p:nvSpPr>
@@ -32424,7 +32529,7 @@
       </p:sp>
       <p:sp>
         <p:nvSpPr>
-          <p:cNvPr id="42" name="text_774"/>
+          <p:cNvPr id="42" name="text_776"/>
           <p:cNvSpPr txBox="1"/>
           <p:nvPr/>
         </p:nvSpPr>
@@ -32579,7 +32684,7 @@
       </p:sp>
       <p:sp>
         <p:nvSpPr>
-          <p:cNvPr id="4" name="card_775"/>
+          <p:cNvPr id="4" name="card_777"/>
           <p:cNvSpPr/>
           <p:nvPr/>
         </p:nvSpPr>
@@ -32608,7 +32713,7 @@
       </p:sp>
       <p:sp>
         <p:nvSpPr>
-          <p:cNvPr id="5" name="chip_776"/>
+          <p:cNvPr id="5" name="chip_778"/>
           <p:cNvSpPr txBox="1"/>
           <p:nvPr/>
         </p:nvSpPr>
@@ -32648,7 +32753,7 @@
       </p:sp>
       <p:sp>
         <p:nvSpPr>
-          <p:cNvPr id="6" name="text_777"/>
+          <p:cNvPr id="6" name="text_779"/>
           <p:cNvSpPr txBox="1"/>
           <p:nvPr/>
         </p:nvSpPr>
@@ -32960,7 +33065,7 @@
       </p:sp>
       <p:sp>
         <p:nvSpPr>
-          <p:cNvPr id="7" name="card_778"/>
+          <p:cNvPr id="7" name="card_780"/>
           <p:cNvSpPr/>
           <p:nvPr/>
         </p:nvSpPr>
@@ -32982,7 +33087,7 @@
       </p:sp>
       <p:sp>
         <p:nvSpPr>
-          <p:cNvPr id="8" name="text_779"/>
+          <p:cNvPr id="8" name="text_781"/>
           <p:cNvSpPr txBox="1"/>
           <p:nvPr/>
         </p:nvSpPr>
@@ -33018,7 +33123,7 @@
       </p:sp>
       <p:sp>
         <p:nvSpPr>
-          <p:cNvPr id="9" name="text_780"/>
+          <p:cNvPr id="9" name="text_782"/>
           <p:cNvSpPr txBox="1"/>
           <p:nvPr/>
         </p:nvSpPr>
@@ -33054,7 +33159,7 @@
       </p:sp>
       <p:sp>
         <p:nvSpPr>
-          <p:cNvPr id="10" name="card_781"/>
+          <p:cNvPr id="10" name="card_783"/>
           <p:cNvSpPr/>
           <p:nvPr/>
         </p:nvSpPr>
@@ -33076,7 +33181,7 @@
       </p:sp>
       <p:sp>
         <p:nvSpPr>
-          <p:cNvPr id="11" name="text_782"/>
+          <p:cNvPr id="11" name="text_784"/>
           <p:cNvSpPr txBox="1"/>
           <p:nvPr/>
         </p:nvSpPr>
@@ -33112,7 +33217,7 @@
       </p:sp>
       <p:sp>
         <p:nvSpPr>
-          <p:cNvPr id="12" name="text_783"/>
+          <p:cNvPr id="12" name="text_785"/>
           <p:cNvSpPr txBox="1"/>
           <p:nvPr/>
         </p:nvSpPr>
@@ -33151,7 +33256,7 @@
       </p:sp>
       <p:sp>
         <p:nvSpPr>
-          <p:cNvPr id="13" name="card_784"/>
+          <p:cNvPr id="13" name="card_786"/>
           <p:cNvSpPr/>
           <p:nvPr/>
         </p:nvSpPr>
@@ -33173,7 +33278,7 @@
       </p:sp>
       <p:sp>
         <p:nvSpPr>
-          <p:cNvPr id="14" name="text_785"/>
+          <p:cNvPr id="14" name="text_787"/>
           <p:cNvSpPr txBox="1"/>
           <p:nvPr/>
         </p:nvSpPr>
@@ -33209,7 +33314,7 @@
       </p:sp>
       <p:sp>
         <p:nvSpPr>
-          <p:cNvPr id="15" name="text_786"/>
+          <p:cNvPr id="15" name="text_788"/>
           <p:cNvSpPr txBox="1"/>
           <p:nvPr/>
         </p:nvSpPr>
@@ -33248,7 +33353,7 @@
       </p:sp>
       <p:sp>
         <p:nvSpPr>
-          <p:cNvPr id="16" name="card_787"/>
+          <p:cNvPr id="16" name="card_789"/>
           <p:cNvSpPr/>
           <p:nvPr/>
         </p:nvSpPr>
@@ -33270,7 +33375,7 @@
       </p:sp>
       <p:sp>
         <p:nvSpPr>
-          <p:cNvPr id="17" name="text_788"/>
+          <p:cNvPr id="17" name="text_790"/>
           <p:cNvSpPr txBox="1"/>
           <p:nvPr/>
         </p:nvSpPr>
@@ -33306,7 +33411,7 @@
       </p:sp>
       <p:sp>
         <p:nvSpPr>
-          <p:cNvPr id="18" name="text_789"/>
+          <p:cNvPr id="18" name="text_791"/>
           <p:cNvSpPr txBox="1"/>
           <p:nvPr/>
         </p:nvSpPr>
@@ -33334,7 +33439,7 @@
                   <a:schemeClr val="tx1"/>
                 </a:solidFill>
               </a:rPr>
-              <a:t>모듈이 없는 스텝은 사람이 XScan으로 스캔해야 한다. 버퍼 값은 소비하는 쪽에서 {B[이름]}으로 참조된다.</a:t>
+              <a:t>모듈이 없는 스텝은 사람이 XScan으로 스캔해야 한다. 비밀번호 같은 값은 프롬프트에 쓰지 말고 TCP 참조 {CP[이름]}로 넣는다. 버퍼 값은 소비하는 쪽에서 {B[이름]}으로 참조된다.</a:t>
             </a:r>
             <a:endParaRPr lang="en-US" sz="1200" dirty="0"/>
           </a:p>
@@ -33450,7 +33555,7 @@
       </p:sp>
       <p:sp>
         <p:nvSpPr>
-          <p:cNvPr id="4" name="card_790"/>
+          <p:cNvPr id="4" name="card_792"/>
           <p:cNvSpPr/>
           <p:nvPr/>
         </p:nvSpPr>
@@ -33472,7 +33577,7 @@
       </p:sp>
       <p:sp>
         <p:nvSpPr>
-          <p:cNvPr id="5" name="badge_791"/>
+          <p:cNvPr id="5" name="badge_793"/>
           <p:cNvSpPr txBox="1"/>
           <p:nvPr/>
         </p:nvSpPr>
@@ -33510,7 +33615,7 @@
       </p:sp>
       <p:sp>
         <p:nvSpPr>
-          <p:cNvPr id="6" name="text_792"/>
+          <p:cNvPr id="6" name="text_794"/>
           <p:cNvSpPr txBox="1"/>
           <p:nvPr/>
         </p:nvSpPr>
@@ -33546,7 +33651,7 @@
       </p:sp>
       <p:sp>
         <p:nvSpPr>
-          <p:cNvPr id="7" name="text_793"/>
+          <p:cNvPr id="7" name="text_795"/>
           <p:cNvSpPr txBox="1"/>
           <p:nvPr/>
         </p:nvSpPr>
@@ -33582,7 +33687,7 @@
       </p:sp>
       <p:sp>
         <p:nvSpPr>
-          <p:cNvPr id="8" name="card_794"/>
+          <p:cNvPr id="8" name="card_796"/>
           <p:cNvSpPr/>
           <p:nvPr/>
         </p:nvSpPr>
@@ -33604,7 +33709,7 @@
       </p:sp>
       <p:sp>
         <p:nvSpPr>
-          <p:cNvPr id="9" name="badge_795"/>
+          <p:cNvPr id="9" name="badge_797"/>
           <p:cNvSpPr txBox="1"/>
           <p:nvPr/>
         </p:nvSpPr>
@@ -33642,7 +33747,7 @@
       </p:sp>
       <p:sp>
         <p:nvSpPr>
-          <p:cNvPr id="10" name="text_796"/>
+          <p:cNvPr id="10" name="text_798"/>
           <p:cNvSpPr txBox="1"/>
           <p:nvPr/>
         </p:nvSpPr>
@@ -33678,7 +33783,7 @@
       </p:sp>
       <p:sp>
         <p:nvSpPr>
-          <p:cNvPr id="11" name="text_797"/>
+          <p:cNvPr id="11" name="text_799"/>
           <p:cNvSpPr txBox="1"/>
           <p:nvPr/>
         </p:nvSpPr>
@@ -33714,7 +33819,7 @@
       </p:sp>
       <p:sp>
         <p:nvSpPr>
-          <p:cNvPr id="12" name="card_798"/>
+          <p:cNvPr id="12" name="card_800"/>
           <p:cNvSpPr/>
           <p:nvPr/>
         </p:nvSpPr>
@@ -33736,7 +33841,7 @@
       </p:sp>
       <p:sp>
         <p:nvSpPr>
-          <p:cNvPr id="13" name="badge_799"/>
+          <p:cNvPr id="13" name="badge_801"/>
           <p:cNvSpPr txBox="1"/>
           <p:nvPr/>
         </p:nvSpPr>
@@ -33774,7 +33879,7 @@
       </p:sp>
       <p:sp>
         <p:nvSpPr>
-          <p:cNvPr id="14" name="text_800"/>
+          <p:cNvPr id="14" name="text_802"/>
           <p:cNvSpPr txBox="1"/>
           <p:nvPr/>
         </p:nvSpPr>
@@ -33810,7 +33915,7 @@
       </p:sp>
       <p:sp>
         <p:nvSpPr>
-          <p:cNvPr id="15" name="text_801"/>
+          <p:cNvPr id="15" name="text_803"/>
           <p:cNvSpPr txBox="1"/>
           <p:nvPr/>
         </p:nvSpPr>
@@ -33846,7 +33951,7 @@
       </p:sp>
       <p:sp>
         <p:nvSpPr>
-          <p:cNvPr id="16" name="card_802"/>
+          <p:cNvPr id="16" name="card_804"/>
           <p:cNvSpPr/>
           <p:nvPr/>
         </p:nvSpPr>
@@ -33870,7 +33975,7 @@
       </p:sp>
       <p:sp>
         <p:nvSpPr>
-          <p:cNvPr id="17" name="badge_803"/>
+          <p:cNvPr id="17" name="badge_805"/>
           <p:cNvSpPr txBox="1"/>
           <p:nvPr/>
         </p:nvSpPr>
@@ -33908,7 +34013,7 @@
       </p:sp>
       <p:sp>
         <p:nvSpPr>
-          <p:cNvPr id="18" name="text_804"/>
+          <p:cNvPr id="18" name="text_806"/>
           <p:cNvSpPr txBox="1"/>
           <p:nvPr/>
         </p:nvSpPr>
@@ -33944,7 +34049,7 @@
       </p:sp>
       <p:sp>
         <p:nvSpPr>
-          <p:cNvPr id="19" name="text_805"/>
+          <p:cNvPr id="19" name="text_807"/>
           <p:cNvSpPr txBox="1"/>
           <p:nvPr/>
         </p:nvSpPr>
@@ -33980,7 +34085,7 @@
       </p:sp>
       <p:sp>
         <p:nvSpPr>
-          <p:cNvPr id="20" name="card_806"/>
+          <p:cNvPr id="20" name="card_808"/>
           <p:cNvSpPr/>
           <p:nvPr/>
         </p:nvSpPr>
@@ -34002,7 +34107,7 @@
       </p:sp>
       <p:sp>
         <p:nvSpPr>
-          <p:cNvPr id="21" name="badge_807"/>
+          <p:cNvPr id="21" name="badge_809"/>
           <p:cNvSpPr txBox="1"/>
           <p:nvPr/>
         </p:nvSpPr>
@@ -34040,7 +34145,7 @@
       </p:sp>
       <p:sp>
         <p:nvSpPr>
-          <p:cNvPr id="22" name="text_808"/>
+          <p:cNvPr id="22" name="text_810"/>
           <p:cNvSpPr txBox="1"/>
           <p:nvPr/>
         </p:nvSpPr>
@@ -34076,7 +34181,7 @@
       </p:sp>
       <p:sp>
         <p:nvSpPr>
-          <p:cNvPr id="23" name="text_809"/>
+          <p:cNvPr id="23" name="text_811"/>
           <p:cNvSpPr txBox="1"/>
           <p:nvPr/>
         </p:nvSpPr>
@@ -34112,7 +34217,7 @@
       </p:sp>
       <p:sp>
         <p:nvSpPr>
-          <p:cNvPr id="24" name="card_810"/>
+          <p:cNvPr id="24" name="card_812"/>
           <p:cNvSpPr/>
           <p:nvPr/>
         </p:nvSpPr>
@@ -34134,7 +34239,7 @@
       </p:sp>
       <p:sp>
         <p:nvSpPr>
-          <p:cNvPr id="25" name="badge_811"/>
+          <p:cNvPr id="25" name="badge_813"/>
           <p:cNvSpPr txBox="1"/>
           <p:nvPr/>
         </p:nvSpPr>
@@ -34172,7 +34277,7 @@
       </p:sp>
       <p:sp>
         <p:nvSpPr>
-          <p:cNvPr id="26" name="text_812"/>
+          <p:cNvPr id="26" name="text_814"/>
           <p:cNvSpPr txBox="1"/>
           <p:nvPr/>
         </p:nvSpPr>
@@ -34208,7 +34313,7 @@
       </p:sp>
       <p:sp>
         <p:nvSpPr>
-          <p:cNvPr id="27" name="text_813"/>
+          <p:cNvPr id="27" name="text_815"/>
           <p:cNvSpPr txBox="1"/>
           <p:nvPr/>
         </p:nvSpPr>
@@ -34244,7 +34349,7 @@
       </p:sp>
       <p:sp>
         <p:nvSpPr>
-          <p:cNvPr id="28" name="card_814"/>
+          <p:cNvPr id="28" name="card_816"/>
           <p:cNvSpPr/>
           <p:nvPr/>
         </p:nvSpPr>
@@ -34271,7 +34376,7 @@
       </p:sp>
       <p:sp>
         <p:nvSpPr>
-          <p:cNvPr id="29" name="iconbg_815"/>
+          <p:cNvPr id="29" name="iconbg_817"/>
           <p:cNvSpPr/>
           <p:nvPr/>
         </p:nvSpPr>
@@ -34291,7 +34396,7 @@
       </p:sp>
       <p:pic>
         <p:nvPicPr>
-          <p:cNvPr id="30" name="icon_816" descr="preencoded.png">    </p:cNvPr>
+          <p:cNvPr id="30" name="icon_818" descr="preencoded.png">    </p:cNvPr>
           <p:cNvPicPr>
             <a:picLocks noChangeAspect="1"/>
           </p:cNvPicPr>
@@ -34315,7 +34420,7 @@
       </p:pic>
       <p:sp>
         <p:nvSpPr>
-          <p:cNvPr id="31" name="text_817"/>
+          <p:cNvPr id="31" name="text_819"/>
           <p:cNvSpPr txBox="1"/>
           <p:nvPr/>
         </p:nvSpPr>
@@ -34357,7 +34462,7 @@
                   <a:schemeClr val="tx1"/>
                 </a:solidFill>
               </a:rPr>
-              <a:t>스킬팩을 설치하면 AI가 공식 워크플로 순서를 스스로 따른다. 템플릿은 그 워크플로에 필요한 정보(경로, 범위, 값, 확인 방식)를 빠짐없이 넘겨주는 역할이다.</a:t>
+              <a:t>스킬팩을 설치하면 AI가 요청에 맞는 공식 워크플로를 골라 순서대로 따른다. 템플릿은 그 워크플로에 필요한 정보(경로, 범위, 값, 확인 방식)를 빠짐없이 넘겨주는 역할이다.</a:t>
             </a:r>
             <a:endParaRPr lang="en-US" sz="1400" dirty="0"/>
           </a:p>
@@ -34473,7 +34578,7 @@
       </p:sp>
       <p:sp>
         <p:nvSpPr>
-          <p:cNvPr id="3" name="badge_818"/>
+          <p:cNvPr id="3" name="badge_820"/>
           <p:cNvSpPr txBox="1"/>
           <p:nvPr/>
         </p:nvSpPr>
@@ -34511,7 +34616,7 @@
       </p:sp>
       <p:sp>
         <p:nvSpPr>
-          <p:cNvPr id="4" name="text_819"/>
+          <p:cNvPr id="4" name="text_821"/>
           <p:cNvSpPr txBox="1"/>
           <p:nvPr/>
         </p:nvSpPr>
@@ -34547,7 +34652,7 @@
       </p:sp>
       <p:sp>
         <p:nvSpPr>
-          <p:cNvPr id="5" name="text_820"/>
+          <p:cNvPr id="5" name="text_822"/>
           <p:cNvSpPr txBox="1"/>
           <p:nvPr/>
         </p:nvSpPr>
@@ -34583,7 +34688,7 @@
       </p:sp>
       <p:sp>
         <p:nvSpPr>
-          <p:cNvPr id="6" name="badge_821"/>
+          <p:cNvPr id="6" name="badge_823"/>
           <p:cNvSpPr txBox="1"/>
           <p:nvPr/>
         </p:nvSpPr>
@@ -34621,7 +34726,7 @@
       </p:sp>
       <p:sp>
         <p:nvSpPr>
-          <p:cNvPr id="7" name="text_822"/>
+          <p:cNvPr id="7" name="text_824"/>
           <p:cNvSpPr txBox="1"/>
           <p:nvPr/>
         </p:nvSpPr>
@@ -34649,7 +34754,7 @@
                   <a:schemeClr val="bg1"/>
                 </a:solidFill>
               </a:rPr>
-              <a:t>AI는 기존 모듈로 만들고, 사람은 계획과 결과를 본다</a:t>
+              <a:t>AI가 만들고, 사람은 계획과 결과를 확인한다</a:t>
             </a:r>
             <a:endParaRPr lang="en-US" sz="1800" dirty="0"/>
           </a:p>
@@ -34657,7 +34762,7 @@
       </p:sp>
       <p:sp>
         <p:nvSpPr>
-          <p:cNvPr id="8" name="text_823"/>
+          <p:cNvPr id="8" name="text_825"/>
           <p:cNvSpPr txBox="1"/>
           <p:nvPr/>
         </p:nvSpPr>
@@ -34685,7 +34790,7 @@
                   <a:schemeClr val="bg2"/>
                 </a:solidFill>
               </a:rPr>
-              <a:t>스캔, 비밀번호, 삭제, 결함 판단은 사람 몫</a:t>
+              <a:t>화면 스캔, 비밀번호, 삭제, 결함 판단은 사람 몫</a:t>
             </a:r>
             <a:endParaRPr lang="en-US" sz="1300" dirty="0"/>
           </a:p>
@@ -34693,7 +34798,7 @@
       </p:sp>
       <p:sp>
         <p:nvSpPr>
-          <p:cNvPr id="9" name="badge_824"/>
+          <p:cNvPr id="9" name="badge_826"/>
           <p:cNvSpPr txBox="1"/>
           <p:nvPr/>
         </p:nvSpPr>
@@ -34731,7 +34836,7 @@
       </p:sp>
       <p:sp>
         <p:nvSpPr>
-          <p:cNvPr id="10" name="text_825"/>
+          <p:cNvPr id="10" name="text_827"/>
           <p:cNvSpPr txBox="1"/>
           <p:nvPr/>
         </p:nvSpPr>
@@ -34767,7 +34872,7 @@
       </p:sp>
       <p:sp>
         <p:nvSpPr>
-          <p:cNvPr id="11" name="text_826"/>
+          <p:cNvPr id="11" name="text_828"/>
           <p:cNvSpPr txBox="1"/>
           <p:nvPr/>
         </p:nvSpPr>
@@ -34803,7 +34908,7 @@
       </p:sp>
       <p:sp>
         <p:nvSpPr>
-          <p:cNvPr id="12" name="next_827"/>
+          <p:cNvPr id="12" name="next_829"/>
           <p:cNvSpPr/>
           <p:nvPr/>
         </p:nvSpPr>
@@ -34827,7 +34932,7 @@
       </p:sp>
       <p:sp>
         <p:nvSpPr>
-          <p:cNvPr id="13" name="text_828"/>
+          <p:cNvPr id="13" name="text_830"/>
           <p:cNvSpPr txBox="1"/>
           <p:nvPr/>
         </p:nvSpPr>
@@ -34863,7 +34968,7 @@
       </p:sp>
       <p:sp>
         <p:nvSpPr>
-          <p:cNvPr id="14" name="text_829"/>
+          <p:cNvPr id="14" name="text_831"/>
           <p:cNvSpPr txBox="1"/>
           <p:nvPr/>
         </p:nvSpPr>
@@ -34939,7 +35044,7 @@
       </p:sp>
       <p:sp>
         <p:nvSpPr>
-          <p:cNvPr id="15" name="text_830"/>
+          <p:cNvPr id="15" name="text_832"/>
           <p:cNvSpPr txBox="1"/>
           <p:nvPr/>
         </p:nvSpPr>
@@ -34975,7 +35080,7 @@
       </p:sp>
       <p:sp>
         <p:nvSpPr>
-          <p:cNvPr id="16" name="text_831"/>
+          <p:cNvPr id="16" name="text_833"/>
           <p:cNvSpPr txBox="1"/>
           <p:nvPr/>
         </p:nvSpPr>
@@ -36138,7 +36243,7 @@
                   <a:schemeClr val="tx1"/>
                 </a:solidFill>
               </a:rPr>
-              <a:t>MCP는 이미 있는 모듈만 재사용한다. 새 화면이나 바뀐 화면은 XScan에서 직접 스캔해야 한다.</a:t>
+              <a:t>AI는 화면을 스캔해 UI 모듈을 만들지 못한다. 새 화면이나 바뀐 화면은 XScan에서 직접 스캔한다.</a:t>
             </a:r>
             <a:endParaRPr lang="en-US" sz="1400" dirty="0"/>
           </a:p>
@@ -36909,7 +37014,7 @@
                   <a:schemeClr val="tx1"/>
                 </a:solidFill>
               </a:rPr>
-              <a:t>흔히 'AI용 USB-C'에 비유</a:t>
+              <a:t>서버 하나로 여러 AI 앱에서 사용</a:t>
             </a:r>
             <a:endParaRPr lang="en-US" sz="1600" dirty="0"/>
           </a:p>
@@ -36945,7 +37050,7 @@
                   <a:schemeClr val="accent6"/>
                 </a:solidFill>
               </a:rPr>
-              <a:t>규격 하나만 맞추면 어느 쪽이든 연결된다</a:t>
+              <a:t>Tosca 쪽은 MCP 서버만 만들면 어느 AI 앱에서든 붙는다</a:t>
             </a:r>
             <a:endParaRPr lang="en-US" sz="1300" dirty="0"/>
           </a:p>
@@ -41085,7 +41190,7 @@
                   <a:schemeClr val="tx1"/>
                 </a:solidFill>
               </a:rPr>
-              <a:t>모듈 5개를 순서대로 끌어다 놓기</a:t>
+              <a:t>모듈을 6번 끌어다 놓아 스텝 만들기</a:t>
             </a:r>
             <a:endParaRPr lang="en-US" sz="1500" dirty="0"/>
           </a:p>
@@ -41855,7 +41960,7 @@
                   <a:schemeClr val="tx2"/>
                 </a:solidFill>
               </a:rPr>
-              <a:t>반복 클릭은 AI가, 판단과 확인은 사람이 한다</a:t>
+              <a:t>클릭은 AI에게 맡기고, 확인은 사람이 직접 한다</a:t>
             </a:r>
             <a:endParaRPr lang="en-US" sz="1800" dirty="0"/>
           </a:p>

</xml_diff>